<commit_message>
Update assessment visuals and track reference replacements
</commit_message>
<xml_diff>
--- a/05_Release/Montazhnik_lesov/01_PPTX/02_No_Test/ML_08_assessment_visual_build_v0.1.pptx
+++ b/05_Release/Montazhnik_lesov/01_PPTX/02_No_Test/ML_08_assessment_visual_build_v0.1.pptx
@@ -290,9 +290,9 @@
           <a:bodyPr/>
           <a:lstStyle/>
           <a:p>
-            <a:fld id="{7C9861D2-7C6A-4A5E-AC57-74F3502DB663}" type="datetimeFigureOut">
+            <a:fld id="{FB1E5C9E-1AC2-4BD6-AA7E-244964439510}" type="datetimeFigureOut">
               <a:rPr lang="ru-RU" smtClean="0"/>
-              <a:t>16.05.2026</a:t>
+              <a:t>18.05.2026</a:t>
             </a:fld>
             <a:endParaRPr lang="ru-RU"/>
           </a:p>
@@ -332,7 +332,7 @@
           <a:bodyPr/>
           <a:lstStyle/>
           <a:p>
-            <a:fld id="{A1BD4C25-6426-4B40-8064-86D59BE50AD4}" type="slidenum">
+            <a:fld id="{CDCE94A6-DE99-42E7-AFCC-E2CC35C44884}" type="slidenum">
               <a:rPr lang="ru-RU" smtClean="0"/>
               <a:t>‹#›</a:t>
             </a:fld>
@@ -343,7 +343,7 @@
     </p:spTree>
     <p:extLst>
       <p:ext uri="{BB962C8B-B14F-4D97-AF65-F5344CB8AC3E}">
-        <p14:creationId xmlns:p14="http://schemas.microsoft.com/office/powerpoint/2010/main" val="3506195081"/>
+        <p14:creationId xmlns:p14="http://schemas.microsoft.com/office/powerpoint/2010/main" val="3447148989"/>
       </p:ext>
     </p:extLst>
   </p:cSld>
@@ -460,9 +460,9 @@
           <a:bodyPr/>
           <a:lstStyle/>
           <a:p>
-            <a:fld id="{7C9861D2-7C6A-4A5E-AC57-74F3502DB663}" type="datetimeFigureOut">
+            <a:fld id="{FB1E5C9E-1AC2-4BD6-AA7E-244964439510}" type="datetimeFigureOut">
               <a:rPr lang="ru-RU" smtClean="0"/>
-              <a:t>16.05.2026</a:t>
+              <a:t>18.05.2026</a:t>
             </a:fld>
             <a:endParaRPr lang="ru-RU"/>
           </a:p>
@@ -502,7 +502,7 @@
           <a:bodyPr/>
           <a:lstStyle/>
           <a:p>
-            <a:fld id="{A1BD4C25-6426-4B40-8064-86D59BE50AD4}" type="slidenum">
+            <a:fld id="{CDCE94A6-DE99-42E7-AFCC-E2CC35C44884}" type="slidenum">
               <a:rPr lang="ru-RU" smtClean="0"/>
               <a:t>‹#›</a:t>
             </a:fld>
@@ -513,7 +513,7 @@
     </p:spTree>
     <p:extLst>
       <p:ext uri="{BB962C8B-B14F-4D97-AF65-F5344CB8AC3E}">
-        <p14:creationId xmlns:p14="http://schemas.microsoft.com/office/powerpoint/2010/main" val="2561163651"/>
+        <p14:creationId xmlns:p14="http://schemas.microsoft.com/office/powerpoint/2010/main" val="3467075821"/>
       </p:ext>
     </p:extLst>
   </p:cSld>
@@ -640,9 +640,9 @@
           <a:bodyPr/>
           <a:lstStyle/>
           <a:p>
-            <a:fld id="{7C9861D2-7C6A-4A5E-AC57-74F3502DB663}" type="datetimeFigureOut">
+            <a:fld id="{FB1E5C9E-1AC2-4BD6-AA7E-244964439510}" type="datetimeFigureOut">
               <a:rPr lang="ru-RU" smtClean="0"/>
-              <a:t>16.05.2026</a:t>
+              <a:t>18.05.2026</a:t>
             </a:fld>
             <a:endParaRPr lang="ru-RU"/>
           </a:p>
@@ -682,7 +682,7 @@
           <a:bodyPr/>
           <a:lstStyle/>
           <a:p>
-            <a:fld id="{A1BD4C25-6426-4B40-8064-86D59BE50AD4}" type="slidenum">
+            <a:fld id="{CDCE94A6-DE99-42E7-AFCC-E2CC35C44884}" type="slidenum">
               <a:rPr lang="ru-RU" smtClean="0"/>
               <a:t>‹#›</a:t>
             </a:fld>
@@ -693,7 +693,7 @@
     </p:spTree>
     <p:extLst>
       <p:ext uri="{BB962C8B-B14F-4D97-AF65-F5344CB8AC3E}">
-        <p14:creationId xmlns:p14="http://schemas.microsoft.com/office/powerpoint/2010/main" val="3251080897"/>
+        <p14:creationId xmlns:p14="http://schemas.microsoft.com/office/powerpoint/2010/main" val="3379536902"/>
       </p:ext>
     </p:extLst>
   </p:cSld>
@@ -810,9 +810,9 @@
           <a:bodyPr/>
           <a:lstStyle/>
           <a:p>
-            <a:fld id="{7C9861D2-7C6A-4A5E-AC57-74F3502DB663}" type="datetimeFigureOut">
+            <a:fld id="{FB1E5C9E-1AC2-4BD6-AA7E-244964439510}" type="datetimeFigureOut">
               <a:rPr lang="ru-RU" smtClean="0"/>
-              <a:t>16.05.2026</a:t>
+              <a:t>18.05.2026</a:t>
             </a:fld>
             <a:endParaRPr lang="ru-RU"/>
           </a:p>
@@ -852,7 +852,7 @@
           <a:bodyPr/>
           <a:lstStyle/>
           <a:p>
-            <a:fld id="{A1BD4C25-6426-4B40-8064-86D59BE50AD4}" type="slidenum">
+            <a:fld id="{CDCE94A6-DE99-42E7-AFCC-E2CC35C44884}" type="slidenum">
               <a:rPr lang="ru-RU" smtClean="0"/>
               <a:t>‹#›</a:t>
             </a:fld>
@@ -863,7 +863,7 @@
     </p:spTree>
     <p:extLst>
       <p:ext uri="{BB962C8B-B14F-4D97-AF65-F5344CB8AC3E}">
-        <p14:creationId xmlns:p14="http://schemas.microsoft.com/office/powerpoint/2010/main" val="3829410020"/>
+        <p14:creationId xmlns:p14="http://schemas.microsoft.com/office/powerpoint/2010/main" val="3327512999"/>
       </p:ext>
     </p:extLst>
   </p:cSld>
@@ -1056,9 +1056,9 @@
           <a:bodyPr/>
           <a:lstStyle/>
           <a:p>
-            <a:fld id="{7C9861D2-7C6A-4A5E-AC57-74F3502DB663}" type="datetimeFigureOut">
+            <a:fld id="{FB1E5C9E-1AC2-4BD6-AA7E-244964439510}" type="datetimeFigureOut">
               <a:rPr lang="ru-RU" smtClean="0"/>
-              <a:t>16.05.2026</a:t>
+              <a:t>18.05.2026</a:t>
             </a:fld>
             <a:endParaRPr lang="ru-RU"/>
           </a:p>
@@ -1098,7 +1098,7 @@
           <a:bodyPr/>
           <a:lstStyle/>
           <a:p>
-            <a:fld id="{A1BD4C25-6426-4B40-8064-86D59BE50AD4}" type="slidenum">
+            <a:fld id="{CDCE94A6-DE99-42E7-AFCC-E2CC35C44884}" type="slidenum">
               <a:rPr lang="ru-RU" smtClean="0"/>
               <a:t>‹#›</a:t>
             </a:fld>
@@ -1109,7 +1109,7 @@
     </p:spTree>
     <p:extLst>
       <p:ext uri="{BB962C8B-B14F-4D97-AF65-F5344CB8AC3E}">
-        <p14:creationId xmlns:p14="http://schemas.microsoft.com/office/powerpoint/2010/main" val="3057705325"/>
+        <p14:creationId xmlns:p14="http://schemas.microsoft.com/office/powerpoint/2010/main" val="1544715322"/>
       </p:ext>
     </p:extLst>
   </p:cSld>
@@ -1344,9 +1344,9 @@
           <a:bodyPr/>
           <a:lstStyle/>
           <a:p>
-            <a:fld id="{7C9861D2-7C6A-4A5E-AC57-74F3502DB663}" type="datetimeFigureOut">
+            <a:fld id="{FB1E5C9E-1AC2-4BD6-AA7E-244964439510}" type="datetimeFigureOut">
               <a:rPr lang="ru-RU" smtClean="0"/>
-              <a:t>16.05.2026</a:t>
+              <a:t>18.05.2026</a:t>
             </a:fld>
             <a:endParaRPr lang="ru-RU"/>
           </a:p>
@@ -1386,7 +1386,7 @@
           <a:bodyPr/>
           <a:lstStyle/>
           <a:p>
-            <a:fld id="{A1BD4C25-6426-4B40-8064-86D59BE50AD4}" type="slidenum">
+            <a:fld id="{CDCE94A6-DE99-42E7-AFCC-E2CC35C44884}" type="slidenum">
               <a:rPr lang="ru-RU" smtClean="0"/>
               <a:t>‹#›</a:t>
             </a:fld>
@@ -1397,7 +1397,7 @@
     </p:spTree>
     <p:extLst>
       <p:ext uri="{BB962C8B-B14F-4D97-AF65-F5344CB8AC3E}">
-        <p14:creationId xmlns:p14="http://schemas.microsoft.com/office/powerpoint/2010/main" val="2498419192"/>
+        <p14:creationId xmlns:p14="http://schemas.microsoft.com/office/powerpoint/2010/main" val="502261505"/>
       </p:ext>
     </p:extLst>
   </p:cSld>
@@ -1771,9 +1771,9 @@
           <a:bodyPr/>
           <a:lstStyle/>
           <a:p>
-            <a:fld id="{7C9861D2-7C6A-4A5E-AC57-74F3502DB663}" type="datetimeFigureOut">
+            <a:fld id="{FB1E5C9E-1AC2-4BD6-AA7E-244964439510}" type="datetimeFigureOut">
               <a:rPr lang="ru-RU" smtClean="0"/>
-              <a:t>16.05.2026</a:t>
+              <a:t>18.05.2026</a:t>
             </a:fld>
             <a:endParaRPr lang="ru-RU"/>
           </a:p>
@@ -1813,7 +1813,7 @@
           <a:bodyPr/>
           <a:lstStyle/>
           <a:p>
-            <a:fld id="{A1BD4C25-6426-4B40-8064-86D59BE50AD4}" type="slidenum">
+            <a:fld id="{CDCE94A6-DE99-42E7-AFCC-E2CC35C44884}" type="slidenum">
               <a:rPr lang="ru-RU" smtClean="0"/>
               <a:t>‹#›</a:t>
             </a:fld>
@@ -1824,7 +1824,7 @@
     </p:spTree>
     <p:extLst>
       <p:ext uri="{BB962C8B-B14F-4D97-AF65-F5344CB8AC3E}">
-        <p14:creationId xmlns:p14="http://schemas.microsoft.com/office/powerpoint/2010/main" val="4152793184"/>
+        <p14:creationId xmlns:p14="http://schemas.microsoft.com/office/powerpoint/2010/main" val="2268884569"/>
       </p:ext>
     </p:extLst>
   </p:cSld>
@@ -1889,9 +1889,9 @@
           <a:bodyPr/>
           <a:lstStyle/>
           <a:p>
-            <a:fld id="{7C9861D2-7C6A-4A5E-AC57-74F3502DB663}" type="datetimeFigureOut">
+            <a:fld id="{FB1E5C9E-1AC2-4BD6-AA7E-244964439510}" type="datetimeFigureOut">
               <a:rPr lang="ru-RU" smtClean="0"/>
-              <a:t>16.05.2026</a:t>
+              <a:t>18.05.2026</a:t>
             </a:fld>
             <a:endParaRPr lang="ru-RU"/>
           </a:p>
@@ -1931,7 +1931,7 @@
           <a:bodyPr/>
           <a:lstStyle/>
           <a:p>
-            <a:fld id="{A1BD4C25-6426-4B40-8064-86D59BE50AD4}" type="slidenum">
+            <a:fld id="{CDCE94A6-DE99-42E7-AFCC-E2CC35C44884}" type="slidenum">
               <a:rPr lang="ru-RU" smtClean="0"/>
               <a:t>‹#›</a:t>
             </a:fld>
@@ -1942,7 +1942,7 @@
     </p:spTree>
     <p:extLst>
       <p:ext uri="{BB962C8B-B14F-4D97-AF65-F5344CB8AC3E}">
-        <p14:creationId xmlns:p14="http://schemas.microsoft.com/office/powerpoint/2010/main" val="2743624425"/>
+        <p14:creationId xmlns:p14="http://schemas.microsoft.com/office/powerpoint/2010/main" val="2319306674"/>
       </p:ext>
     </p:extLst>
   </p:cSld>
@@ -1984,9 +1984,9 @@
           <a:bodyPr/>
           <a:lstStyle/>
           <a:p>
-            <a:fld id="{7C9861D2-7C6A-4A5E-AC57-74F3502DB663}" type="datetimeFigureOut">
+            <a:fld id="{FB1E5C9E-1AC2-4BD6-AA7E-244964439510}" type="datetimeFigureOut">
               <a:rPr lang="ru-RU" smtClean="0"/>
-              <a:t>16.05.2026</a:t>
+              <a:t>18.05.2026</a:t>
             </a:fld>
             <a:endParaRPr lang="ru-RU"/>
           </a:p>
@@ -2026,7 +2026,7 @@
           <a:bodyPr/>
           <a:lstStyle/>
           <a:p>
-            <a:fld id="{A1BD4C25-6426-4B40-8064-86D59BE50AD4}" type="slidenum">
+            <a:fld id="{CDCE94A6-DE99-42E7-AFCC-E2CC35C44884}" type="slidenum">
               <a:rPr lang="ru-RU" smtClean="0"/>
               <a:t>‹#›</a:t>
             </a:fld>
@@ -2037,7 +2037,7 @@
     </p:spTree>
     <p:extLst>
       <p:ext uri="{BB962C8B-B14F-4D97-AF65-F5344CB8AC3E}">
-        <p14:creationId xmlns:p14="http://schemas.microsoft.com/office/powerpoint/2010/main" val="2126102263"/>
+        <p14:creationId xmlns:p14="http://schemas.microsoft.com/office/powerpoint/2010/main" val="2315265473"/>
       </p:ext>
     </p:extLst>
   </p:cSld>
@@ -2261,9 +2261,9 @@
           <a:bodyPr/>
           <a:lstStyle/>
           <a:p>
-            <a:fld id="{7C9861D2-7C6A-4A5E-AC57-74F3502DB663}" type="datetimeFigureOut">
+            <a:fld id="{FB1E5C9E-1AC2-4BD6-AA7E-244964439510}" type="datetimeFigureOut">
               <a:rPr lang="ru-RU" smtClean="0"/>
-              <a:t>16.05.2026</a:t>
+              <a:t>18.05.2026</a:t>
             </a:fld>
             <a:endParaRPr lang="ru-RU"/>
           </a:p>
@@ -2303,7 +2303,7 @@
           <a:bodyPr/>
           <a:lstStyle/>
           <a:p>
-            <a:fld id="{A1BD4C25-6426-4B40-8064-86D59BE50AD4}" type="slidenum">
+            <a:fld id="{CDCE94A6-DE99-42E7-AFCC-E2CC35C44884}" type="slidenum">
               <a:rPr lang="ru-RU" smtClean="0"/>
               <a:t>‹#›</a:t>
             </a:fld>
@@ -2314,7 +2314,7 @@
     </p:spTree>
     <p:extLst>
       <p:ext uri="{BB962C8B-B14F-4D97-AF65-F5344CB8AC3E}">
-        <p14:creationId xmlns:p14="http://schemas.microsoft.com/office/powerpoint/2010/main" val="3800794913"/>
+        <p14:creationId xmlns:p14="http://schemas.microsoft.com/office/powerpoint/2010/main" val="1125103528"/>
       </p:ext>
     </p:extLst>
   </p:cSld>
@@ -2514,9 +2514,9 @@
           <a:bodyPr/>
           <a:lstStyle/>
           <a:p>
-            <a:fld id="{7C9861D2-7C6A-4A5E-AC57-74F3502DB663}" type="datetimeFigureOut">
+            <a:fld id="{FB1E5C9E-1AC2-4BD6-AA7E-244964439510}" type="datetimeFigureOut">
               <a:rPr lang="ru-RU" smtClean="0"/>
-              <a:t>16.05.2026</a:t>
+              <a:t>18.05.2026</a:t>
             </a:fld>
             <a:endParaRPr lang="ru-RU"/>
           </a:p>
@@ -2556,7 +2556,7 @@
           <a:bodyPr/>
           <a:lstStyle/>
           <a:p>
-            <a:fld id="{A1BD4C25-6426-4B40-8064-86D59BE50AD4}" type="slidenum">
+            <a:fld id="{CDCE94A6-DE99-42E7-AFCC-E2CC35C44884}" type="slidenum">
               <a:rPr lang="ru-RU" smtClean="0"/>
               <a:t>‹#›</a:t>
             </a:fld>
@@ -2567,7 +2567,7 @@
     </p:spTree>
     <p:extLst>
       <p:ext uri="{BB962C8B-B14F-4D97-AF65-F5344CB8AC3E}">
-        <p14:creationId xmlns:p14="http://schemas.microsoft.com/office/powerpoint/2010/main" val="1594330641"/>
+        <p14:creationId xmlns:p14="http://schemas.microsoft.com/office/powerpoint/2010/main" val="332728815"/>
       </p:ext>
     </p:extLst>
   </p:cSld>
@@ -2727,9 +2727,9 @@
             </a:lvl1pPr>
           </a:lstStyle>
           <a:p>
-            <a:fld id="{7C9861D2-7C6A-4A5E-AC57-74F3502DB663}" type="datetimeFigureOut">
+            <a:fld id="{FB1E5C9E-1AC2-4BD6-AA7E-244964439510}" type="datetimeFigureOut">
               <a:rPr lang="ru-RU" smtClean="0"/>
-              <a:t>16.05.2026</a:t>
+              <a:t>18.05.2026</a:t>
             </a:fld>
             <a:endParaRPr lang="ru-RU"/>
           </a:p>
@@ -2805,7 +2805,7 @@
             </a:lvl1pPr>
           </a:lstStyle>
           <a:p>
-            <a:fld id="{A1BD4C25-6426-4B40-8064-86D59BE50AD4}" type="slidenum">
+            <a:fld id="{CDCE94A6-DE99-42E7-AFCC-E2CC35C44884}" type="slidenum">
               <a:rPr lang="ru-RU" smtClean="0"/>
               <a:t>‹#›</a:t>
             </a:fld>
@@ -2816,7 +2816,7 @@
     </p:spTree>
     <p:extLst>
       <p:ext uri="{BB962C8B-B14F-4D97-AF65-F5344CB8AC3E}">
-        <p14:creationId xmlns:p14="http://schemas.microsoft.com/office/powerpoint/2010/main" val="3321664648"/>
+        <p14:creationId xmlns:p14="http://schemas.microsoft.com/office/powerpoint/2010/main" val="1051844874"/>
       </p:ext>
     </p:extLst>
   </p:cSld>
@@ -3340,7 +3340,7 @@
                 </a:solidFill>
                 <a:latin typeface="Segoe UI"/>
               </a:rPr>
-              <a:t>Rabochaya ploshchadka dolzhna schityvatsya kak otdelnaya rol gruppy elementov</a:t>
+              <a:t>Rabochaya ploshchadka schityvaetsya otdelno ot svyazey i krepleniy</a:t>
             </a:r>
             <a:endParaRPr lang="ru-RU" sz="2500" b="1">
               <a:solidFill>
@@ -3380,7 +3380,7 @@
                 </a:solidFill>
                 <a:latin typeface="Segoe UI"/>
               </a:rPr>
-              <a:t>Etot board nuzhen dlya bystrogo raspoznavaniya: chto dayot rabochuyu ploshchadku, chto derzhit zhestkost, a chto fiksiruet skhemu.</a:t>
+              <a:t>Board dolzhen bystro pokazyvat rol gruppy: chto dayot poverkhnost dlya raboty, chto derzhit zhestkost i chto fiksiruet uzel.</a:t>
             </a:r>
             <a:endParaRPr lang="ru-RU" sz="1300">
               <a:solidFill>
@@ -3475,7 +3475,7 @@
                 </a:solidFill>
                 <a:latin typeface="Segoe UI"/>
               </a:rPr>
-              <a:t>Test prompt: ukazhite gruppu, kotoraya formiruet rabochuyu ploshchadku</a:t>
+              <a:t>Q-07: kakaya gruppa formiruet rabochuyu ploshchadku?</a:t>
             </a:r>
             <a:endParaRPr lang="ru-RU" sz="1000" b="1">
               <a:solidFill>
@@ -3664,436 +3664,12 @@
         </p:nvSpPr>
         <p:spPr>
           <a:xfrm>
-            <a:off x="762000" y="2489200"/>
-            <a:ext cx="5689600" cy="3098800"/>
+            <a:off x="685800" y="2463800"/>
+            <a:ext cx="3352800" cy="3302000"/>
           </a:xfrm>
           <a:prstGeom prst="roundRect">
             <a:avLst>
-              <a:gd name="adj" fmla="val 8000"/>
-            </a:avLst>
-          </a:prstGeom>
-          <a:solidFill>
-            <a:srgbClr val="FFFFFF"/>
-          </a:solidFill>
-          <a:ln w="15875" cap="flat" cmpd="sng" algn="ctr">
-            <a:solidFill>
-              <a:srgbClr val="BAC6CF"/>
-            </a:solidFill>
-            <a:prstDash val="solid"/>
-            <a:round/>
-            <a:headEnd type="none" w="med" len="med"/>
-            <a:tailEnd type="none" w="med" len="med"/>
-          </a:ln>
-        </p:spPr>
-        <p:style>
-          <a:lnRef idx="2">
-            <a:schemeClr val="accent1">
-              <a:shade val="50000"/>
-            </a:schemeClr>
-          </a:lnRef>
-          <a:fillRef idx="1">
-            <a:schemeClr val="accent1"/>
-          </a:fillRef>
-          <a:effectRef idx="0">
-            <a:schemeClr val="accent1"/>
-          </a:effectRef>
-          <a:fontRef idx="minor">
-            <a:schemeClr val="lt1"/>
-          </a:fontRef>
-        </p:style>
-        <p:txBody>
-          <a:bodyPr rtlCol="0" anchor="ctr"/>
-          <a:lstStyle/>
-          <a:p>
-            <a:pPr algn="ctr"/>
-            <a:endParaRPr lang="ru-RU"/>
-          </a:p>
-        </p:txBody>
-      </p:sp>
-      <p:sp>
-        <p:nvSpPr>
-          <p:cNvPr id="15" name="TextBox 14"/>
-          <p:cNvSpPr txBox="1"/>
-          <p:nvPr/>
-        </p:nvSpPr>
-        <p:spPr>
-          <a:xfrm>
-            <a:off x="965200" y="2641600"/>
-            <a:ext cx="2794000" cy="369332"/>
-          </a:xfrm>
-          <a:prstGeom prst="rect">
-            <a:avLst/>
-          </a:prstGeom>
-          <a:noFill/>
-        </p:spPr>
-        <p:txBody>
-          <a:bodyPr vert="horz" wrap="square" lIns="0" tIns="0" rIns="0" bIns="0" rtlCol="0" anchor="ctr">
-            <a:noAutofit/>
-          </a:bodyPr>
-          <a:lstStyle/>
-          <a:p>
-            <a:r>
-              <a:rPr lang="en-US" sz="1400" b="1" smtClean="0">
-                <a:solidFill>
-                  <a:srgbClr val="17324D"/>
-                </a:solidFill>
-                <a:latin typeface="Segoe UI"/>
-              </a:rPr>
-              <a:t>Recognition scheme</a:t>
-            </a:r>
-            <a:endParaRPr lang="ru-RU" sz="1400" b="1">
-              <a:solidFill>
-                <a:srgbClr val="17324D"/>
-              </a:solidFill>
-              <a:latin typeface="Segoe UI"/>
-            </a:endParaRPr>
-          </a:p>
-        </p:txBody>
-      </p:sp>
-      <p:sp>
-        <p:nvSpPr>
-          <p:cNvPr id="16" name="Прямоугольник 15"/>
-          <p:cNvSpPr/>
-          <p:nvPr/>
-        </p:nvSpPr>
-        <p:spPr>
-          <a:xfrm>
-            <a:off x="3022600" y="2997200"/>
-            <a:ext cx="1168400" cy="1905000"/>
-          </a:xfrm>
-          <a:prstGeom prst="rect">
-            <a:avLst/>
-          </a:prstGeom>
-          <a:solidFill>
-            <a:srgbClr val="E6EEF4"/>
-          </a:solidFill>
-          <a:ln w="25400" cap="flat" cmpd="sng" algn="ctr">
-            <a:solidFill>
-              <a:srgbClr val="8FA3B7"/>
-            </a:solidFill>
-            <a:prstDash val="solid"/>
-            <a:round/>
-            <a:headEnd type="none" w="med" len="med"/>
-            <a:tailEnd type="none" w="med" len="med"/>
-          </a:ln>
-        </p:spPr>
-        <p:style>
-          <a:lnRef idx="2">
-            <a:schemeClr val="accent1">
-              <a:shade val="50000"/>
-            </a:schemeClr>
-          </a:lnRef>
-          <a:fillRef idx="1">
-            <a:schemeClr val="accent1"/>
-          </a:fillRef>
-          <a:effectRef idx="0">
-            <a:schemeClr val="accent1"/>
-          </a:effectRef>
-          <a:fontRef idx="minor">
-            <a:schemeClr val="lt1"/>
-          </a:fontRef>
-        </p:style>
-        <p:txBody>
-          <a:bodyPr rtlCol="0" anchor="ctr"/>
-          <a:lstStyle/>
-          <a:p>
-            <a:pPr algn="ctr"/>
-            <a:endParaRPr lang="ru-RU"/>
-          </a:p>
-        </p:txBody>
-      </p:sp>
-      <p:sp>
-        <p:nvSpPr>
-          <p:cNvPr id="17" name="Прямоугольник 16"/>
-          <p:cNvSpPr/>
-          <p:nvPr/>
-        </p:nvSpPr>
-        <p:spPr>
-          <a:xfrm>
-            <a:off x="2235200" y="3632200"/>
-            <a:ext cx="2743200" cy="279400"/>
-          </a:xfrm>
-          <a:prstGeom prst="rect">
-            <a:avLst/>
-          </a:prstGeom>
-          <a:solidFill>
-            <a:srgbClr val="E8F3EC"/>
-          </a:solidFill>
-          <a:ln w="25400" cap="flat" cmpd="sng" algn="ctr">
-            <a:solidFill>
-              <a:srgbClr val="2E7D5B"/>
-            </a:solidFill>
-            <a:prstDash val="solid"/>
-            <a:round/>
-            <a:headEnd type="none" w="med" len="med"/>
-            <a:tailEnd type="none" w="med" len="med"/>
-          </a:ln>
-        </p:spPr>
-        <p:style>
-          <a:lnRef idx="2">
-            <a:schemeClr val="accent1">
-              <a:shade val="50000"/>
-            </a:schemeClr>
-          </a:lnRef>
-          <a:fillRef idx="1">
-            <a:schemeClr val="accent1"/>
-          </a:fillRef>
-          <a:effectRef idx="0">
-            <a:schemeClr val="accent1"/>
-          </a:effectRef>
-          <a:fontRef idx="minor">
-            <a:schemeClr val="lt1"/>
-          </a:fontRef>
-        </p:style>
-        <p:txBody>
-          <a:bodyPr rtlCol="0" anchor="ctr"/>
-          <a:lstStyle/>
-          <a:p>
-            <a:pPr algn="ctr"/>
-            <a:endParaRPr lang="ru-RU"/>
-          </a:p>
-        </p:txBody>
-      </p:sp>
-      <p:cxnSp>
-        <p:nvCxnSpPr>
-          <p:cNvPr id="18" name="Прямая соединительная линия 17"/>
-          <p:cNvCxnSpPr/>
-          <p:nvPr/>
-        </p:nvCxnSpPr>
-        <p:spPr>
-          <a:xfrm flipH="1">
-            <a:off x="2235200" y="3073400"/>
-            <a:ext cx="787400" cy="1117600"/>
-          </a:xfrm>
-          <a:prstGeom prst="line">
-            <a:avLst/>
-          </a:prstGeom>
-          <a:ln w="38100">
-            <a:solidFill>
-              <a:srgbClr val="D58B22"/>
-            </a:solidFill>
-          </a:ln>
-        </p:spPr>
-        <p:style>
-          <a:lnRef idx="1">
-            <a:schemeClr val="accent1"/>
-          </a:lnRef>
-          <a:fillRef idx="0">
-            <a:schemeClr val="accent1"/>
-          </a:fillRef>
-          <a:effectRef idx="0">
-            <a:schemeClr val="accent1"/>
-          </a:effectRef>
-          <a:fontRef idx="minor">
-            <a:schemeClr val="tx1"/>
-          </a:fontRef>
-        </p:style>
-      </p:cxnSp>
-      <p:cxnSp>
-        <p:nvCxnSpPr>
-          <p:cNvPr id="19" name="Прямая соединительная линия 18"/>
-          <p:cNvCxnSpPr/>
-          <p:nvPr/>
-        </p:nvCxnSpPr>
-        <p:spPr>
-          <a:xfrm>
-            <a:off x="4191000" y="3073400"/>
-            <a:ext cx="787400" cy="1117600"/>
-          </a:xfrm>
-          <a:prstGeom prst="line">
-            <a:avLst/>
-          </a:prstGeom>
-          <a:ln w="38100">
-            <a:solidFill>
-              <a:srgbClr val="D58B22"/>
-            </a:solidFill>
-          </a:ln>
-        </p:spPr>
-        <p:style>
-          <a:lnRef idx="1">
-            <a:schemeClr val="accent1"/>
-          </a:lnRef>
-          <a:fillRef idx="0">
-            <a:schemeClr val="accent1"/>
-          </a:fillRef>
-          <a:effectRef idx="0">
-            <a:schemeClr val="accent1"/>
-          </a:effectRef>
-          <a:fontRef idx="minor">
-            <a:schemeClr val="tx1"/>
-          </a:fontRef>
-        </p:style>
-      </p:cxnSp>
-      <p:sp>
-        <p:nvSpPr>
-          <p:cNvPr id="20" name="Овал 19"/>
-          <p:cNvSpPr/>
-          <p:nvPr/>
-        </p:nvSpPr>
-        <p:spPr>
-          <a:xfrm>
-            <a:off x="2819400" y="4927600"/>
-            <a:ext cx="203200" cy="203200"/>
-          </a:xfrm>
-          <a:prstGeom prst="ellipse">
-            <a:avLst/>
-          </a:prstGeom>
-          <a:solidFill>
-            <a:srgbClr val="8E4A76"/>
-          </a:solidFill>
-          <a:ln w="25400" cap="flat" cmpd="sng" algn="ctr">
-            <a:noFill/>
-            <a:prstDash val="solid"/>
-          </a:ln>
-          <a:effectLst/>
-          <a:extLst>
-            <a:ext uri="{91240B29-F687-4F45-9708-019B960494DF}">
-              <a14:hiddenLine xmlns:a14="http://schemas.microsoft.com/office/drawing/2010/main" w="25400" cap="flat" cmpd="sng" algn="ctr">
-                <a:solidFill>
-                  <a:schemeClr val="accent1">
-                    <a:shade val="50000"/>
-                  </a:schemeClr>
-                </a:solidFill>
-                <a:prstDash val="solid"/>
-              </a14:hiddenLine>
-            </a:ext>
-          </a:extLst>
-        </p:spPr>
-        <p:style>
-          <a:lnRef idx="2">
-            <a:schemeClr val="accent1">
-              <a:shade val="50000"/>
-            </a:schemeClr>
-          </a:lnRef>
-          <a:fillRef idx="1">
-            <a:schemeClr val="accent1"/>
-          </a:fillRef>
-          <a:effectRef idx="0">
-            <a:schemeClr val="accent1"/>
-          </a:effectRef>
-          <a:fontRef idx="minor">
-            <a:schemeClr val="lt1"/>
-          </a:fontRef>
-        </p:style>
-        <p:txBody>
-          <a:bodyPr rtlCol="0" anchor="ctr"/>
-          <a:lstStyle/>
-          <a:p>
-            <a:pPr algn="ctr"/>
-            <a:endParaRPr lang="ru-RU"/>
-          </a:p>
-        </p:txBody>
-      </p:sp>
-      <p:sp>
-        <p:nvSpPr>
-          <p:cNvPr id="21" name="Овал 20"/>
-          <p:cNvSpPr/>
-          <p:nvPr/>
-        </p:nvSpPr>
-        <p:spPr>
-          <a:xfrm>
-            <a:off x="4191000" y="4927600"/>
-            <a:ext cx="203200" cy="203200"/>
-          </a:xfrm>
-          <a:prstGeom prst="ellipse">
-            <a:avLst/>
-          </a:prstGeom>
-          <a:solidFill>
-            <a:srgbClr val="8E4A76"/>
-          </a:solidFill>
-          <a:ln w="25400" cap="flat" cmpd="sng" algn="ctr">
-            <a:noFill/>
-            <a:prstDash val="solid"/>
-          </a:ln>
-          <a:effectLst/>
-          <a:extLst>
-            <a:ext uri="{91240B29-F687-4F45-9708-019B960494DF}">
-              <a14:hiddenLine xmlns:a14="http://schemas.microsoft.com/office/drawing/2010/main" w="25400" cap="flat" cmpd="sng" algn="ctr">
-                <a:solidFill>
-                  <a:schemeClr val="accent1">
-                    <a:shade val="50000"/>
-                  </a:schemeClr>
-                </a:solidFill>
-                <a:prstDash val="solid"/>
-              </a14:hiddenLine>
-            </a:ext>
-          </a:extLst>
-        </p:spPr>
-        <p:style>
-          <a:lnRef idx="2">
-            <a:schemeClr val="accent1">
-              <a:shade val="50000"/>
-            </a:schemeClr>
-          </a:lnRef>
-          <a:fillRef idx="1">
-            <a:schemeClr val="accent1"/>
-          </a:fillRef>
-          <a:effectRef idx="0">
-            <a:schemeClr val="accent1"/>
-          </a:effectRef>
-          <a:fontRef idx="minor">
-            <a:schemeClr val="lt1"/>
-          </a:fontRef>
-        </p:style>
-        <p:txBody>
-          <a:bodyPr rtlCol="0" anchor="ctr"/>
-          <a:lstStyle/>
-          <a:p>
-            <a:pPr algn="ctr"/>
-            <a:endParaRPr lang="ru-RU"/>
-          </a:p>
-        </p:txBody>
-      </p:sp>
-      <p:cxnSp>
-        <p:nvCxnSpPr>
-          <p:cNvPr id="22" name="Прямая соединительная линия 21"/>
-          <p:cNvCxnSpPr/>
-          <p:nvPr/>
-        </p:nvCxnSpPr>
-        <p:spPr>
-          <a:xfrm flipH="1">
-            <a:off x="4648200" y="3022600"/>
-            <a:ext cx="2082800" cy="762000"/>
-          </a:xfrm>
-          <a:prstGeom prst="line">
-            <a:avLst/>
-          </a:prstGeom>
-          <a:ln w="22860">
-            <a:solidFill>
-              <a:srgbClr val="2E7D5B"/>
-            </a:solidFill>
-            <a:tailEnd type="arrow"/>
-          </a:ln>
-        </p:spPr>
-        <p:style>
-          <a:lnRef idx="1">
-            <a:schemeClr val="accent1"/>
-          </a:lnRef>
-          <a:fillRef idx="0">
-            <a:schemeClr val="accent1"/>
-          </a:fillRef>
-          <a:effectRef idx="0">
-            <a:schemeClr val="accent1"/>
-          </a:effectRef>
-          <a:fontRef idx="minor">
-            <a:schemeClr val="tx1"/>
-          </a:fontRef>
-        </p:style>
-      </p:cxnSp>
-      <p:sp>
-        <p:nvSpPr>
-          <p:cNvPr id="23" name="Скругленный прямоугольник 22"/>
-          <p:cNvSpPr/>
-          <p:nvPr/>
-        </p:nvSpPr>
-        <p:spPr>
-          <a:xfrm>
-            <a:off x="6807200" y="2667000"/>
-            <a:ext cx="4318000" cy="787400"/>
-          </a:xfrm>
-          <a:prstGeom prst="roundRect">
-            <a:avLst>
-              <a:gd name="adj" fmla="val 12000"/>
+              <a:gd name="adj" fmla="val 10000"/>
             </a:avLst>
           </a:prstGeom>
           <a:solidFill>
@@ -4134,18 +3710,57 @@
           </a:p>
         </p:txBody>
       </p:sp>
-      <p:sp>
-        <p:nvSpPr>
-          <p:cNvPr id="24" name="Овал 23"/>
+      <p:pic>
+        <p:nvPicPr>
+          <p:cNvPr id="15" name="Рисунок 14"/>
+          <p:cNvPicPr>
+            <a:picLocks/>
+          </p:cNvPicPr>
+          <p:nvPr/>
+        </p:nvPicPr>
+        <p:blipFill>
+          <a:blip r:embed="rId2">
+            <a:extLst>
+              <a:ext uri="{28A0092B-C50C-407E-A947-70E740481C1C}">
+                <a14:useLocalDpi xmlns:a14="http://schemas.microsoft.com/office/drawing/2010/main" val="0"/>
+              </a:ext>
+            </a:extLst>
+          </a:blip>
+          <a:stretch>
+            <a:fillRect/>
+          </a:stretch>
+        </p:blipFill>
+        <p:spPr>
+          <a:xfrm>
+            <a:off x="901700" y="2667000"/>
+            <a:ext cx="2921000" cy="1879600"/>
+          </a:xfrm>
+          <a:prstGeom prst="rect">
+            <a:avLst/>
+          </a:prstGeom>
+          <a:ln w="9525" cap="flat" cmpd="sng" algn="ctr">
+            <a:solidFill>
+              <a:srgbClr val="D4DCE3"/>
+            </a:solidFill>
+            <a:prstDash val="solid"/>
+            <a:round/>
+            <a:headEnd type="none" w="med" len="med"/>
+            <a:tailEnd type="none" w="med" len="med"/>
+          </a:ln>
+        </p:spPr>
+      </p:pic>
+      <p:sp>
+        <p:nvSpPr>
+          <p:cNvPr id="16" name="Прямоугольник 15"/>
           <p:cNvSpPr/>
           <p:nvPr/>
         </p:nvSpPr>
         <p:spPr>
           <a:xfrm>
-            <a:off x="6959600" y="2832100"/>
-            <a:ext cx="127000" cy="127000"/>
-          </a:xfrm>
-          <a:prstGeom prst="ellipse">
+            <a:off x="901700" y="4597400"/>
+            <a:ext cx="2921000" cy="76200"/>
+          </a:xfrm>
+          <a:prstGeom prst="rect">
             <a:avLst/>
           </a:prstGeom>
           <a:solidFill>
@@ -4196,14 +3811,140 @@
       </p:sp>
       <p:sp>
         <p:nvSpPr>
-          <p:cNvPr id="25" name="TextBox 24"/>
+          <p:cNvPr id="17" name="Скругленный прямоугольник 16"/>
+          <p:cNvSpPr/>
+          <p:nvPr/>
+        </p:nvSpPr>
+        <p:spPr>
+          <a:xfrm>
+            <a:off x="901700" y="4800600"/>
+            <a:ext cx="2921000" cy="355600"/>
+          </a:xfrm>
+          <a:prstGeom prst="roundRect">
+            <a:avLst>
+              <a:gd name="adj" fmla="val 16000"/>
+            </a:avLst>
+          </a:prstGeom>
+          <a:solidFill>
+            <a:srgbClr val="535861"/>
+          </a:solidFill>
+          <a:ln w="15875" cap="flat" cmpd="sng" algn="ctr">
+            <a:noFill/>
+            <a:prstDash val="solid"/>
+            <a:round/>
+            <a:headEnd type="none" w="med" len="med"/>
+            <a:tailEnd type="none" w="med" len="med"/>
+          </a:ln>
+          <a:effectLst/>
+          <a:extLst>
+            <a:ext uri="{91240B29-F687-4F45-9708-019B960494DF}">
+              <a14:hiddenLine xmlns:a14="http://schemas.microsoft.com/office/drawing/2010/main" w="15875" cap="flat" cmpd="sng" algn="ctr">
+                <a:solidFill>
+                  <a:srgbClr val="535861"/>
+                </a:solidFill>
+                <a:prstDash val="solid"/>
+                <a:round/>
+                <a:headEnd type="none" w="med" len="med"/>
+                <a:tailEnd type="none" w="med" len="med"/>
+              </a14:hiddenLine>
+            </a:ext>
+          </a:extLst>
+        </p:spPr>
+        <p:style>
+          <a:lnRef idx="2">
+            <a:schemeClr val="accent1">
+              <a:shade val="50000"/>
+            </a:schemeClr>
+          </a:lnRef>
+          <a:fillRef idx="1">
+            <a:schemeClr val="accent1"/>
+          </a:fillRef>
+          <a:effectRef idx="0">
+            <a:schemeClr val="accent1"/>
+          </a:effectRef>
+          <a:fontRef idx="minor">
+            <a:schemeClr val="lt1"/>
+          </a:fontRef>
+        </p:style>
+        <p:txBody>
+          <a:bodyPr rtlCol="0" anchor="ctr"/>
+          <a:lstStyle/>
+          <a:p>
+            <a:pPr algn="ctr"/>
+            <a:endParaRPr lang="ru-RU"/>
+          </a:p>
+        </p:txBody>
+      </p:sp>
+      <p:sp>
+        <p:nvSpPr>
+          <p:cNvPr id="18" name="Овал 17"/>
+          <p:cNvSpPr/>
+          <p:nvPr/>
+        </p:nvSpPr>
+        <p:spPr>
+          <a:xfrm>
+            <a:off x="1041400" y="4914900"/>
+            <a:ext cx="127000" cy="127000"/>
+          </a:xfrm>
+          <a:prstGeom prst="ellipse">
+            <a:avLst/>
+          </a:prstGeom>
+          <a:solidFill>
+            <a:srgbClr val="2E7D5B"/>
+          </a:solidFill>
+          <a:ln w="25400" cap="flat" cmpd="sng" algn="ctr">
+            <a:noFill/>
+            <a:prstDash val="solid"/>
+          </a:ln>
+          <a:effectLst/>
+          <a:extLst>
+            <a:ext uri="{91240B29-F687-4F45-9708-019B960494DF}">
+              <a14:hiddenLine xmlns:a14="http://schemas.microsoft.com/office/drawing/2010/main" w="25400" cap="flat" cmpd="sng" algn="ctr">
+                <a:solidFill>
+                  <a:schemeClr val="accent1">
+                    <a:shade val="50000"/>
+                  </a:schemeClr>
+                </a:solidFill>
+                <a:prstDash val="solid"/>
+              </a14:hiddenLine>
+            </a:ext>
+          </a:extLst>
+        </p:spPr>
+        <p:style>
+          <a:lnRef idx="2">
+            <a:schemeClr val="accent1">
+              <a:shade val="50000"/>
+            </a:schemeClr>
+          </a:lnRef>
+          <a:fillRef idx="1">
+            <a:schemeClr val="accent1"/>
+          </a:fillRef>
+          <a:effectRef idx="0">
+            <a:schemeClr val="accent1"/>
+          </a:effectRef>
+          <a:fontRef idx="minor">
+            <a:schemeClr val="lt1"/>
+          </a:fontRef>
+        </p:style>
+        <p:txBody>
+          <a:bodyPr rtlCol="0" anchor="ctr"/>
+          <a:lstStyle/>
+          <a:p>
+            <a:pPr algn="ctr"/>
+            <a:endParaRPr lang="ru-RU"/>
+          </a:p>
+        </p:txBody>
+      </p:sp>
+      <p:sp>
+        <p:nvSpPr>
+          <p:cNvPr id="19" name="TextBox 18"/>
           <p:cNvSpPr txBox="1"/>
           <p:nvPr/>
         </p:nvSpPr>
         <p:spPr>
           <a:xfrm>
-            <a:off x="7162800" y="2768600"/>
-            <a:ext cx="3835400" cy="369332"/>
+            <a:off x="1244600" y="4838700"/>
+            <a:ext cx="2438400" cy="369332"/>
           </a:xfrm>
           <a:prstGeom prst="rect">
             <a:avLst/>
@@ -4217,17 +3958,17 @@
           <a:lstStyle/>
           <a:p>
             <a:r>
-              <a:rPr lang="en-US" sz="1250" b="1" smtClean="0">
-                <a:solidFill>
-                  <a:srgbClr val="17324D"/>
-                </a:solidFill>
-                <a:latin typeface="Segoe UI"/>
-              </a:rPr>
-              <a:t>Badge 1: nastily / rabochaya ploshchadka</a:t>
-            </a:r>
-            <a:endParaRPr lang="ru-RU" sz="1250" b="1">
+              <a:rPr lang="en-US" sz="1120" b="1" smtClean="0">
+                <a:solidFill>
+                  <a:srgbClr val="FFFFFF"/>
+                </a:solidFill>
+                <a:latin typeface="Segoe UI"/>
+              </a:rPr>
+              <a:t>Nastily / rabochaya ploshchadka</a:t>
+            </a:r>
+            <a:endParaRPr lang="ru-RU" sz="1120" b="1">
               <a:solidFill>
-                <a:srgbClr val="17324D"/>
+                <a:srgbClr val="FFFFFF"/>
               </a:solidFill>
               <a:latin typeface="Segoe UI"/>
             </a:endParaRPr>
@@ -4236,14 +3977,14 @@
       </p:sp>
       <p:sp>
         <p:nvSpPr>
-          <p:cNvPr id="26" name="TextBox 25"/>
+          <p:cNvPr id="20" name="TextBox 19"/>
           <p:cNvSpPr txBox="1"/>
           <p:nvPr/>
         </p:nvSpPr>
         <p:spPr>
           <a:xfrm>
-            <a:off x="7162800" y="3048000"/>
-            <a:ext cx="3835400" cy="369332"/>
+            <a:off x="901700" y="5232400"/>
+            <a:ext cx="2921000" cy="369332"/>
           </a:xfrm>
           <a:prstGeom prst="rect">
             <a:avLst/>
@@ -4257,73 +3998,37 @@
           <a:lstStyle/>
           <a:p>
             <a:r>
-              <a:rPr lang="en-US" sz="1080" smtClean="0">
-                <a:solidFill>
-                  <a:srgbClr val="4A5968"/>
-                </a:solidFill>
-                <a:latin typeface="Segoe UI"/>
-              </a:rPr>
-              <a:t>Imenno eta gruppa dolzhna byt pravilnym fokusom otveta na Q-07.</a:t>
-            </a:r>
-            <a:endParaRPr lang="ru-RU" sz="1080">
+              <a:rPr lang="en-US" sz="1040" smtClean="0">
+                <a:solidFill>
+                  <a:srgbClr val="465564"/>
+                </a:solidFill>
+                <a:latin typeface="Segoe UI"/>
+              </a:rPr>
+              <a:t>Na etoy gruppe rabotayut. Eto pravilnyy fokus dlya Q-07.</a:t>
+            </a:r>
+            <a:endParaRPr lang="ru-RU" sz="1040">
               <a:solidFill>
-                <a:srgbClr val="4A5968"/>
+                <a:srgbClr val="465564"/>
               </a:solidFill>
               <a:latin typeface="Segoe UI"/>
             </a:endParaRPr>
           </a:p>
         </p:txBody>
       </p:sp>
-      <p:cxnSp>
-        <p:nvCxnSpPr>
-          <p:cNvPr id="27" name="Прямая соединительная линия 26"/>
-          <p:cNvCxnSpPr/>
-          <p:nvPr/>
-        </p:nvCxnSpPr>
-        <p:spPr>
-          <a:xfrm flipH="1" flipV="1">
-            <a:off x="3733800" y="3378200"/>
-            <a:ext cx="2997200" cy="558800"/>
-          </a:xfrm>
-          <a:prstGeom prst="line">
-            <a:avLst/>
-          </a:prstGeom>
-          <a:ln w="22860">
-            <a:solidFill>
-              <a:srgbClr val="D58B22"/>
-            </a:solidFill>
-            <a:tailEnd type="arrow"/>
-          </a:ln>
-        </p:spPr>
-        <p:style>
-          <a:lnRef idx="1">
-            <a:schemeClr val="accent1"/>
-          </a:lnRef>
-          <a:fillRef idx="0">
-            <a:schemeClr val="accent1"/>
-          </a:fillRef>
-          <a:effectRef idx="0">
-            <a:schemeClr val="accent1"/>
-          </a:effectRef>
-          <a:fontRef idx="minor">
-            <a:schemeClr val="tx1"/>
-          </a:fontRef>
-        </p:style>
-      </p:cxnSp>
-      <p:sp>
-        <p:nvSpPr>
-          <p:cNvPr id="28" name="Скругленный прямоугольник 27"/>
+      <p:sp>
+        <p:nvSpPr>
+          <p:cNvPr id="21" name="Скругленный прямоугольник 20"/>
           <p:cNvSpPr/>
           <p:nvPr/>
         </p:nvSpPr>
         <p:spPr>
           <a:xfrm>
-            <a:off x="6807200" y="3632200"/>
-            <a:ext cx="4318000" cy="787400"/>
+            <a:off x="4419600" y="2463800"/>
+            <a:ext cx="3352800" cy="3302000"/>
           </a:xfrm>
           <a:prstGeom prst="roundRect">
             <a:avLst>
-              <a:gd name="adj" fmla="val 12000"/>
+              <a:gd name="adj" fmla="val 10000"/>
             </a:avLst>
           </a:prstGeom>
           <a:solidFill>
@@ -4364,18 +4069,57 @@
           </a:p>
         </p:txBody>
       </p:sp>
-      <p:sp>
-        <p:nvSpPr>
-          <p:cNvPr id="29" name="Овал 28"/>
+      <p:pic>
+        <p:nvPicPr>
+          <p:cNvPr id="22" name="Рисунок 21"/>
+          <p:cNvPicPr>
+            <a:picLocks/>
+          </p:cNvPicPr>
+          <p:nvPr/>
+        </p:nvPicPr>
+        <p:blipFill>
+          <a:blip r:embed="rId3">
+            <a:extLst>
+              <a:ext uri="{28A0092B-C50C-407E-A947-70E740481C1C}">
+                <a14:useLocalDpi xmlns:a14="http://schemas.microsoft.com/office/drawing/2010/main" val="0"/>
+              </a:ext>
+            </a:extLst>
+          </a:blip>
+          <a:stretch>
+            <a:fillRect/>
+          </a:stretch>
+        </p:blipFill>
+        <p:spPr>
+          <a:xfrm>
+            <a:off x="4635500" y="2667000"/>
+            <a:ext cx="2921000" cy="1879600"/>
+          </a:xfrm>
+          <a:prstGeom prst="rect">
+            <a:avLst/>
+          </a:prstGeom>
+          <a:ln w="9525" cap="flat" cmpd="sng" algn="ctr">
+            <a:solidFill>
+              <a:srgbClr val="D4DCE3"/>
+            </a:solidFill>
+            <a:prstDash val="solid"/>
+            <a:round/>
+            <a:headEnd type="none" w="med" len="med"/>
+            <a:tailEnd type="none" w="med" len="med"/>
+          </a:ln>
+        </p:spPr>
+      </p:pic>
+      <p:sp>
+        <p:nvSpPr>
+          <p:cNvPr id="23" name="Прямоугольник 22"/>
           <p:cNvSpPr/>
           <p:nvPr/>
         </p:nvSpPr>
         <p:spPr>
           <a:xfrm>
-            <a:off x="6959600" y="3797300"/>
-            <a:ext cx="127000" cy="127000"/>
-          </a:xfrm>
-          <a:prstGeom prst="ellipse">
+            <a:off x="4635500" y="4597400"/>
+            <a:ext cx="2921000" cy="76200"/>
+          </a:xfrm>
+          <a:prstGeom prst="rect">
             <a:avLst/>
           </a:prstGeom>
           <a:solidFill>
@@ -4426,14 +4170,140 @@
       </p:sp>
       <p:sp>
         <p:nvSpPr>
-          <p:cNvPr id="30" name="TextBox 29"/>
+          <p:cNvPr id="24" name="Скругленный прямоугольник 23"/>
+          <p:cNvSpPr/>
+          <p:nvPr/>
+        </p:nvSpPr>
+        <p:spPr>
+          <a:xfrm>
+            <a:off x="4635500" y="4800600"/>
+            <a:ext cx="2921000" cy="355600"/>
+          </a:xfrm>
+          <a:prstGeom prst="roundRect">
+            <a:avLst>
+              <a:gd name="adj" fmla="val 16000"/>
+            </a:avLst>
+          </a:prstGeom>
+          <a:solidFill>
+            <a:srgbClr val="535861"/>
+          </a:solidFill>
+          <a:ln w="15875" cap="flat" cmpd="sng" algn="ctr">
+            <a:noFill/>
+            <a:prstDash val="solid"/>
+            <a:round/>
+            <a:headEnd type="none" w="med" len="med"/>
+            <a:tailEnd type="none" w="med" len="med"/>
+          </a:ln>
+          <a:effectLst/>
+          <a:extLst>
+            <a:ext uri="{91240B29-F687-4F45-9708-019B960494DF}">
+              <a14:hiddenLine xmlns:a14="http://schemas.microsoft.com/office/drawing/2010/main" w="15875" cap="flat" cmpd="sng" algn="ctr">
+                <a:solidFill>
+                  <a:srgbClr val="535861"/>
+                </a:solidFill>
+                <a:prstDash val="solid"/>
+                <a:round/>
+                <a:headEnd type="none" w="med" len="med"/>
+                <a:tailEnd type="none" w="med" len="med"/>
+              </a14:hiddenLine>
+            </a:ext>
+          </a:extLst>
+        </p:spPr>
+        <p:style>
+          <a:lnRef idx="2">
+            <a:schemeClr val="accent1">
+              <a:shade val="50000"/>
+            </a:schemeClr>
+          </a:lnRef>
+          <a:fillRef idx="1">
+            <a:schemeClr val="accent1"/>
+          </a:fillRef>
+          <a:effectRef idx="0">
+            <a:schemeClr val="accent1"/>
+          </a:effectRef>
+          <a:fontRef idx="minor">
+            <a:schemeClr val="lt1"/>
+          </a:fontRef>
+        </p:style>
+        <p:txBody>
+          <a:bodyPr rtlCol="0" anchor="ctr"/>
+          <a:lstStyle/>
+          <a:p>
+            <a:pPr algn="ctr"/>
+            <a:endParaRPr lang="ru-RU"/>
+          </a:p>
+        </p:txBody>
+      </p:sp>
+      <p:sp>
+        <p:nvSpPr>
+          <p:cNvPr id="25" name="Овал 24"/>
+          <p:cNvSpPr/>
+          <p:nvPr/>
+        </p:nvSpPr>
+        <p:spPr>
+          <a:xfrm>
+            <a:off x="4775200" y="4914900"/>
+            <a:ext cx="127000" cy="127000"/>
+          </a:xfrm>
+          <a:prstGeom prst="ellipse">
+            <a:avLst/>
+          </a:prstGeom>
+          <a:solidFill>
+            <a:srgbClr val="D58B22"/>
+          </a:solidFill>
+          <a:ln w="25400" cap="flat" cmpd="sng" algn="ctr">
+            <a:noFill/>
+            <a:prstDash val="solid"/>
+          </a:ln>
+          <a:effectLst/>
+          <a:extLst>
+            <a:ext uri="{91240B29-F687-4F45-9708-019B960494DF}">
+              <a14:hiddenLine xmlns:a14="http://schemas.microsoft.com/office/drawing/2010/main" w="25400" cap="flat" cmpd="sng" algn="ctr">
+                <a:solidFill>
+                  <a:schemeClr val="accent1">
+                    <a:shade val="50000"/>
+                  </a:schemeClr>
+                </a:solidFill>
+                <a:prstDash val="solid"/>
+              </a14:hiddenLine>
+            </a:ext>
+          </a:extLst>
+        </p:spPr>
+        <p:style>
+          <a:lnRef idx="2">
+            <a:schemeClr val="accent1">
+              <a:shade val="50000"/>
+            </a:schemeClr>
+          </a:lnRef>
+          <a:fillRef idx="1">
+            <a:schemeClr val="accent1"/>
+          </a:fillRef>
+          <a:effectRef idx="0">
+            <a:schemeClr val="accent1"/>
+          </a:effectRef>
+          <a:fontRef idx="minor">
+            <a:schemeClr val="lt1"/>
+          </a:fontRef>
+        </p:style>
+        <p:txBody>
+          <a:bodyPr rtlCol="0" anchor="ctr"/>
+          <a:lstStyle/>
+          <a:p>
+            <a:pPr algn="ctr"/>
+            <a:endParaRPr lang="ru-RU"/>
+          </a:p>
+        </p:txBody>
+      </p:sp>
+      <p:sp>
+        <p:nvSpPr>
+          <p:cNvPr id="26" name="TextBox 25"/>
           <p:cNvSpPr txBox="1"/>
           <p:nvPr/>
         </p:nvSpPr>
         <p:spPr>
           <a:xfrm>
-            <a:off x="7162800" y="3733800"/>
-            <a:ext cx="3835400" cy="369332"/>
+            <a:off x="4978400" y="4838700"/>
+            <a:ext cx="2438400" cy="369332"/>
           </a:xfrm>
           <a:prstGeom prst="rect">
             <a:avLst/>
@@ -4447,17 +4317,17 @@
           <a:lstStyle/>
           <a:p>
             <a:r>
-              <a:rPr lang="en-US" sz="1250" b="1" smtClean="0">
-                <a:solidFill>
-                  <a:srgbClr val="17324D"/>
-                </a:solidFill>
-                <a:latin typeface="Segoe UI"/>
-              </a:rPr>
-              <a:t>Badge 2: svyazi / zhestkost</a:t>
-            </a:r>
-            <a:endParaRPr lang="ru-RU" sz="1250" b="1">
+              <a:rPr lang="en-US" sz="1120" b="1" smtClean="0">
+                <a:solidFill>
+                  <a:srgbClr val="FFFFFF"/>
+                </a:solidFill>
+                <a:latin typeface="Segoe UI"/>
+              </a:rPr>
+              <a:t>Svyazi / zhestkost</a:t>
+            </a:r>
+            <a:endParaRPr lang="ru-RU" sz="1120" b="1">
               <a:solidFill>
-                <a:srgbClr val="17324D"/>
+                <a:srgbClr val="FFFFFF"/>
               </a:solidFill>
               <a:latin typeface="Segoe UI"/>
             </a:endParaRPr>
@@ -4466,14 +4336,14 @@
       </p:sp>
       <p:sp>
         <p:nvSpPr>
-          <p:cNvPr id="31" name="TextBox 30"/>
+          <p:cNvPr id="27" name="TextBox 26"/>
           <p:cNvSpPr txBox="1"/>
           <p:nvPr/>
         </p:nvSpPr>
         <p:spPr>
           <a:xfrm>
-            <a:off x="7162800" y="4013200"/>
-            <a:ext cx="3835400" cy="369332"/>
+            <a:off x="4635500" y="5232400"/>
+            <a:ext cx="2921000" cy="369332"/>
           </a:xfrm>
           <a:prstGeom prst="rect">
             <a:avLst/>
@@ -4487,73 +4357,37 @@
           <a:lstStyle/>
           <a:p>
             <a:r>
-              <a:rPr lang="en-US" sz="1080" smtClean="0">
-                <a:solidFill>
-                  <a:srgbClr val="4A5968"/>
-                </a:solidFill>
-                <a:latin typeface="Segoe UI"/>
-              </a:rPr>
-              <a:t>Eta gruppa derzhit geometriyu, no ne yavlyaetsya rabochey ploshchadkoy.</a:t>
-            </a:r>
-            <a:endParaRPr lang="ru-RU" sz="1080">
+              <a:rPr lang="en-US" sz="1040" smtClean="0">
+                <a:solidFill>
+                  <a:srgbClr val="465564"/>
+                </a:solidFill>
+                <a:latin typeface="Segoe UI"/>
+              </a:rPr>
+              <a:t>Derzhat geometriyu i zhestkost, no ne formiruyut rabochuyu ploshchadku.</a:t>
+            </a:r>
+            <a:endParaRPr lang="ru-RU" sz="1040">
               <a:solidFill>
-                <a:srgbClr val="4A5968"/>
+                <a:srgbClr val="465564"/>
               </a:solidFill>
               <a:latin typeface="Segoe UI"/>
             </a:endParaRPr>
           </a:p>
         </p:txBody>
       </p:sp>
-      <p:cxnSp>
-        <p:nvCxnSpPr>
-          <p:cNvPr id="32" name="Прямая соединительная линия 31"/>
-          <p:cNvCxnSpPr/>
-          <p:nvPr/>
-        </p:nvCxnSpPr>
-        <p:spPr>
-          <a:xfrm flipH="1">
-            <a:off x="4292600" y="4851400"/>
-            <a:ext cx="2438400" cy="177800"/>
-          </a:xfrm>
-          <a:prstGeom prst="line">
-            <a:avLst/>
-          </a:prstGeom>
-          <a:ln w="22860">
-            <a:solidFill>
-              <a:srgbClr val="8E4A76"/>
-            </a:solidFill>
-            <a:tailEnd type="arrow"/>
-          </a:ln>
-        </p:spPr>
-        <p:style>
-          <a:lnRef idx="1">
-            <a:schemeClr val="accent1"/>
-          </a:lnRef>
-          <a:fillRef idx="0">
-            <a:schemeClr val="accent1"/>
-          </a:fillRef>
-          <a:effectRef idx="0">
-            <a:schemeClr val="accent1"/>
-          </a:effectRef>
-          <a:fontRef idx="minor">
-            <a:schemeClr val="tx1"/>
-          </a:fontRef>
-        </p:style>
-      </p:cxnSp>
-      <p:sp>
-        <p:nvSpPr>
-          <p:cNvPr id="33" name="Скругленный прямоугольник 32"/>
+      <p:sp>
+        <p:nvSpPr>
+          <p:cNvPr id="28" name="Скругленный прямоугольник 27"/>
           <p:cNvSpPr/>
           <p:nvPr/>
         </p:nvSpPr>
         <p:spPr>
           <a:xfrm>
-            <a:off x="6807200" y="4597400"/>
-            <a:ext cx="4318000" cy="787400"/>
+            <a:off x="8153400" y="2463800"/>
+            <a:ext cx="3352800" cy="3302000"/>
           </a:xfrm>
           <a:prstGeom prst="roundRect">
             <a:avLst>
-              <a:gd name="adj" fmla="val 12000"/>
+              <a:gd name="adj" fmla="val 10000"/>
             </a:avLst>
           </a:prstGeom>
           <a:solidFill>
@@ -4594,18 +4428,57 @@
           </a:p>
         </p:txBody>
       </p:sp>
-      <p:sp>
-        <p:nvSpPr>
-          <p:cNvPr id="34" name="Овал 33"/>
+      <p:pic>
+        <p:nvPicPr>
+          <p:cNvPr id="29" name="Рисунок 28"/>
+          <p:cNvPicPr>
+            <a:picLocks/>
+          </p:cNvPicPr>
+          <p:nvPr/>
+        </p:nvPicPr>
+        <p:blipFill>
+          <a:blip r:embed="rId4">
+            <a:extLst>
+              <a:ext uri="{28A0092B-C50C-407E-A947-70E740481C1C}">
+                <a14:useLocalDpi xmlns:a14="http://schemas.microsoft.com/office/drawing/2010/main" val="0"/>
+              </a:ext>
+            </a:extLst>
+          </a:blip>
+          <a:stretch>
+            <a:fillRect/>
+          </a:stretch>
+        </p:blipFill>
+        <p:spPr>
+          <a:xfrm>
+            <a:off x="8369300" y="2667000"/>
+            <a:ext cx="2921000" cy="1879600"/>
+          </a:xfrm>
+          <a:prstGeom prst="rect">
+            <a:avLst/>
+          </a:prstGeom>
+          <a:ln w="9525" cap="flat" cmpd="sng" algn="ctr">
+            <a:solidFill>
+              <a:srgbClr val="D4DCE3"/>
+            </a:solidFill>
+            <a:prstDash val="solid"/>
+            <a:round/>
+            <a:headEnd type="none" w="med" len="med"/>
+            <a:tailEnd type="none" w="med" len="med"/>
+          </a:ln>
+        </p:spPr>
+      </p:pic>
+      <p:sp>
+        <p:nvSpPr>
+          <p:cNvPr id="30" name="Прямоугольник 29"/>
           <p:cNvSpPr/>
           <p:nvPr/>
         </p:nvSpPr>
         <p:spPr>
           <a:xfrm>
-            <a:off x="6959600" y="4762500"/>
-            <a:ext cx="127000" cy="127000"/>
-          </a:xfrm>
-          <a:prstGeom prst="ellipse">
+            <a:off x="8369300" y="4597400"/>
+            <a:ext cx="2921000" cy="76200"/>
+          </a:xfrm>
+          <a:prstGeom prst="rect">
             <a:avLst/>
           </a:prstGeom>
           <a:solidFill>
@@ -4656,112 +4529,44 @@
       </p:sp>
       <p:sp>
         <p:nvSpPr>
-          <p:cNvPr id="35" name="TextBox 34"/>
-          <p:cNvSpPr txBox="1"/>
-          <p:nvPr/>
-        </p:nvSpPr>
-        <p:spPr>
-          <a:xfrm>
-            <a:off x="7162800" y="4699000"/>
-            <a:ext cx="3835400" cy="369332"/>
-          </a:xfrm>
-          <a:prstGeom prst="rect">
-            <a:avLst/>
-          </a:prstGeom>
-          <a:noFill/>
-        </p:spPr>
-        <p:txBody>
-          <a:bodyPr vert="horz" wrap="square" lIns="0" tIns="0" rIns="0" bIns="0" rtlCol="0" anchor="ctr">
-            <a:noAutofit/>
-          </a:bodyPr>
-          <a:lstStyle/>
-          <a:p>
-            <a:r>
-              <a:rPr lang="en-US" sz="1250" b="1" smtClean="0">
-                <a:solidFill>
-                  <a:srgbClr val="17324D"/>
-                </a:solidFill>
-                <a:latin typeface="Segoe UI"/>
-              </a:rPr>
-              <a:t>Badge 3: kreplenie / fiksatsiya</a:t>
-            </a:r>
-            <a:endParaRPr lang="ru-RU" sz="1250" b="1">
-              <a:solidFill>
-                <a:srgbClr val="17324D"/>
-              </a:solidFill>
-              <a:latin typeface="Segoe UI"/>
-            </a:endParaRPr>
-          </a:p>
-        </p:txBody>
-      </p:sp>
-      <p:sp>
-        <p:nvSpPr>
-          <p:cNvPr id="36" name="TextBox 35"/>
-          <p:cNvSpPr txBox="1"/>
-          <p:nvPr/>
-        </p:nvSpPr>
-        <p:spPr>
-          <a:xfrm>
-            <a:off x="7162800" y="4978400"/>
-            <a:ext cx="3835400" cy="369332"/>
-          </a:xfrm>
-          <a:prstGeom prst="rect">
-            <a:avLst/>
-          </a:prstGeom>
-          <a:noFill/>
-        </p:spPr>
-        <p:txBody>
-          <a:bodyPr vert="horz" wrap="square" lIns="0" tIns="0" rIns="0" bIns="0" rtlCol="0" anchor="ctr">
-            <a:noAutofit/>
-          </a:bodyPr>
-          <a:lstStyle/>
-          <a:p>
-            <a:r>
-              <a:rPr lang="en-US" sz="1080" smtClean="0">
-                <a:solidFill>
-                  <a:srgbClr val="4A5968"/>
-                </a:solidFill>
-                <a:latin typeface="Segoe UI"/>
-              </a:rPr>
-              <a:t>Kreplenie uderzhivaet skhemu i ne dolzhno podmenyat soboy roli drugih grupp.</a:t>
-            </a:r>
-            <a:endParaRPr lang="ru-RU" sz="1080">
-              <a:solidFill>
-                <a:srgbClr val="4A5968"/>
-              </a:solidFill>
-              <a:latin typeface="Segoe UI"/>
-            </a:endParaRPr>
-          </a:p>
-        </p:txBody>
-      </p:sp>
-      <p:sp>
-        <p:nvSpPr>
-          <p:cNvPr id="37" name="Скругленный прямоугольник 36"/>
+          <p:cNvPr id="31" name="Скругленный прямоугольник 30"/>
           <p:cNvSpPr/>
           <p:nvPr/>
         </p:nvSpPr>
         <p:spPr>
           <a:xfrm>
-            <a:off x="939800" y="5207000"/>
-            <a:ext cx="2489200" cy="279400"/>
+            <a:off x="8369300" y="4800600"/>
+            <a:ext cx="2921000" cy="355600"/>
           </a:xfrm>
           <a:prstGeom prst="roundRect">
             <a:avLst>
-              <a:gd name="adj" fmla="val 18000"/>
+              <a:gd name="adj" fmla="val 16000"/>
             </a:avLst>
           </a:prstGeom>
           <a:solidFill>
-            <a:srgbClr val="6C7A89"/>
+            <a:srgbClr val="535861"/>
           </a:solidFill>
           <a:ln w="15875" cap="flat" cmpd="sng" algn="ctr">
-            <a:solidFill>
-              <a:srgbClr val="6C7A89"/>
-            </a:solidFill>
+            <a:noFill/>
             <a:prstDash val="solid"/>
             <a:round/>
             <a:headEnd type="none" w="med" len="med"/>
             <a:tailEnd type="none" w="med" len="med"/>
           </a:ln>
+          <a:effectLst/>
+          <a:extLst>
+            <a:ext uri="{91240B29-F687-4F45-9708-019B960494DF}">
+              <a14:hiddenLine xmlns:a14="http://schemas.microsoft.com/office/drawing/2010/main" w="15875" cap="flat" cmpd="sng" algn="ctr">
+                <a:solidFill>
+                  <a:srgbClr val="535861"/>
+                </a:solidFill>
+                <a:prstDash val="solid"/>
+                <a:round/>
+                <a:headEnd type="none" w="med" len="med"/>
+                <a:tailEnd type="none" w="med" len="med"/>
+              </a14:hiddenLine>
+            </a:ext>
+          </a:extLst>
         </p:spPr>
         <p:style>
           <a:lnRef idx="2">
@@ -4790,14 +4595,74 @@
       </p:sp>
       <p:sp>
         <p:nvSpPr>
-          <p:cNvPr id="38" name="TextBox 37"/>
+          <p:cNvPr id="32" name="Овал 31"/>
+          <p:cNvSpPr/>
+          <p:nvPr/>
+        </p:nvSpPr>
+        <p:spPr>
+          <a:xfrm>
+            <a:off x="8509000" y="4914900"/>
+            <a:ext cx="127000" cy="127000"/>
+          </a:xfrm>
+          <a:prstGeom prst="ellipse">
+            <a:avLst/>
+          </a:prstGeom>
+          <a:solidFill>
+            <a:srgbClr val="8E4A76"/>
+          </a:solidFill>
+          <a:ln w="25400" cap="flat" cmpd="sng" algn="ctr">
+            <a:noFill/>
+            <a:prstDash val="solid"/>
+          </a:ln>
+          <a:effectLst/>
+          <a:extLst>
+            <a:ext uri="{91240B29-F687-4F45-9708-019B960494DF}">
+              <a14:hiddenLine xmlns:a14="http://schemas.microsoft.com/office/drawing/2010/main" w="25400" cap="flat" cmpd="sng" algn="ctr">
+                <a:solidFill>
+                  <a:schemeClr val="accent1">
+                    <a:shade val="50000"/>
+                  </a:schemeClr>
+                </a:solidFill>
+                <a:prstDash val="solid"/>
+              </a14:hiddenLine>
+            </a:ext>
+          </a:extLst>
+        </p:spPr>
+        <p:style>
+          <a:lnRef idx="2">
+            <a:schemeClr val="accent1">
+              <a:shade val="50000"/>
+            </a:schemeClr>
+          </a:lnRef>
+          <a:fillRef idx="1">
+            <a:schemeClr val="accent1"/>
+          </a:fillRef>
+          <a:effectRef idx="0">
+            <a:schemeClr val="accent1"/>
+          </a:effectRef>
+          <a:fontRef idx="minor">
+            <a:schemeClr val="lt1"/>
+          </a:fontRef>
+        </p:style>
+        <p:txBody>
+          <a:bodyPr rtlCol="0" anchor="ctr"/>
+          <a:lstStyle/>
+          <a:p>
+            <a:pPr algn="ctr"/>
+            <a:endParaRPr lang="ru-RU"/>
+          </a:p>
+        </p:txBody>
+      </p:sp>
+      <p:sp>
+        <p:nvSpPr>
+          <p:cNvPr id="33" name="TextBox 32"/>
           <p:cNvSpPr txBox="1"/>
           <p:nvPr/>
         </p:nvSpPr>
         <p:spPr>
           <a:xfrm>
-            <a:off x="939800" y="5232400"/>
-            <a:ext cx="2489200" cy="369332"/>
+            <a:off x="8712200" y="4838700"/>
+            <a:ext cx="2438400" cy="369332"/>
           </a:xfrm>
           <a:prstGeom prst="rect">
             <a:avLst/>
@@ -4810,7 +4675,195 @@
           </a:bodyPr>
           <a:lstStyle/>
           <a:p>
+            <a:r>
+              <a:rPr lang="en-US" sz="1120" b="1" smtClean="0">
+                <a:solidFill>
+                  <a:srgbClr val="FFFFFF"/>
+                </a:solidFill>
+                <a:latin typeface="Segoe UI"/>
+              </a:rPr>
+              <a:t>Kreplenie / fiksatsiya</a:t>
+            </a:r>
+            <a:endParaRPr lang="ru-RU" sz="1120" b="1">
+              <a:solidFill>
+                <a:srgbClr val="FFFFFF"/>
+              </a:solidFill>
+              <a:latin typeface="Segoe UI"/>
+            </a:endParaRPr>
+          </a:p>
+        </p:txBody>
+      </p:sp>
+      <p:sp>
+        <p:nvSpPr>
+          <p:cNvPr id="34" name="TextBox 33"/>
+          <p:cNvSpPr txBox="1"/>
+          <p:nvPr/>
+        </p:nvSpPr>
+        <p:spPr>
+          <a:xfrm>
+            <a:off x="8369300" y="5232400"/>
+            <a:ext cx="2921000" cy="369332"/>
+          </a:xfrm>
+          <a:prstGeom prst="rect">
+            <a:avLst/>
+          </a:prstGeom>
+          <a:noFill/>
+        </p:spPr>
+        <p:txBody>
+          <a:bodyPr vert="horz" wrap="square" lIns="0" tIns="0" rIns="0" bIns="0" rtlCol="0" anchor="ctr">
+            <a:noAutofit/>
+          </a:bodyPr>
+          <a:lstStyle/>
+          <a:p>
+            <a:r>
+              <a:rPr lang="en-US" sz="1040" smtClean="0">
+                <a:solidFill>
+                  <a:srgbClr val="465564"/>
+                </a:solidFill>
+                <a:latin typeface="Segoe UI"/>
+              </a:rPr>
+              <a:t>Uderzhivaet uzel i skhemu, no ne yavlyaetsya rabochey ploshchadkoy.</a:t>
+            </a:r>
+            <a:endParaRPr lang="ru-RU" sz="1040">
+              <a:solidFill>
+                <a:srgbClr val="465564"/>
+              </a:solidFill>
+              <a:latin typeface="Segoe UI"/>
+            </a:endParaRPr>
+          </a:p>
+        </p:txBody>
+      </p:sp>
+      <p:sp>
+        <p:nvSpPr>
+          <p:cNvPr id="35" name="Скругленный прямоугольник 34"/>
+          <p:cNvSpPr/>
+          <p:nvPr/>
+        </p:nvSpPr>
+        <p:spPr>
+          <a:xfrm>
+            <a:off x="2438400" y="5842000"/>
+            <a:ext cx="7315200" cy="304800"/>
+          </a:xfrm>
+          <a:prstGeom prst="roundRect">
+            <a:avLst>
+              <a:gd name="adj" fmla="val 14000"/>
+            </a:avLst>
+          </a:prstGeom>
+          <a:solidFill>
+            <a:srgbClr val="FFF3E8"/>
+          </a:solidFill>
+          <a:ln w="15875" cap="flat" cmpd="sng" algn="ctr">
+            <a:solidFill>
+              <a:srgbClr val="E4B07E"/>
+            </a:solidFill>
+            <a:prstDash val="solid"/>
+            <a:round/>
+            <a:headEnd type="none" w="med" len="med"/>
+            <a:tailEnd type="none" w="med" len="med"/>
+          </a:ln>
+        </p:spPr>
+        <p:style>
+          <a:lnRef idx="2">
+            <a:schemeClr val="accent1">
+              <a:shade val="50000"/>
+            </a:schemeClr>
+          </a:lnRef>
+          <a:fillRef idx="1">
+            <a:schemeClr val="accent1"/>
+          </a:fillRef>
+          <a:effectRef idx="0">
+            <a:schemeClr val="accent1"/>
+          </a:effectRef>
+          <a:fontRef idx="minor">
+            <a:schemeClr val="lt1"/>
+          </a:fontRef>
+        </p:style>
+        <p:txBody>
+          <a:bodyPr rtlCol="0" anchor="ctr"/>
+          <a:lstStyle/>
+          <a:p>
             <a:pPr algn="ctr"/>
+            <a:endParaRPr lang="ru-RU"/>
+          </a:p>
+        </p:txBody>
+      </p:sp>
+      <p:sp>
+        <p:nvSpPr>
+          <p:cNvPr id="36" name="Скругленный прямоугольник 35"/>
+          <p:cNvSpPr/>
+          <p:nvPr/>
+        </p:nvSpPr>
+        <p:spPr>
+          <a:xfrm>
+            <a:off x="2616200" y="5854700"/>
+            <a:ext cx="1168400" cy="279400"/>
+          </a:xfrm>
+          <a:prstGeom prst="roundRect">
+            <a:avLst>
+              <a:gd name="adj" fmla="val 18000"/>
+            </a:avLst>
+          </a:prstGeom>
+          <a:solidFill>
+            <a:srgbClr val="C65D18"/>
+          </a:solidFill>
+          <a:ln w="15875" cap="flat" cmpd="sng" algn="ctr">
+            <a:solidFill>
+              <a:srgbClr val="C65D18"/>
+            </a:solidFill>
+            <a:prstDash val="solid"/>
+            <a:round/>
+            <a:headEnd type="none" w="med" len="med"/>
+            <a:tailEnd type="none" w="med" len="med"/>
+          </a:ln>
+        </p:spPr>
+        <p:style>
+          <a:lnRef idx="2">
+            <a:schemeClr val="accent1">
+              <a:shade val="50000"/>
+            </a:schemeClr>
+          </a:lnRef>
+          <a:fillRef idx="1">
+            <a:schemeClr val="accent1"/>
+          </a:fillRef>
+          <a:effectRef idx="0">
+            <a:schemeClr val="accent1"/>
+          </a:effectRef>
+          <a:fontRef idx="minor">
+            <a:schemeClr val="lt1"/>
+          </a:fontRef>
+        </p:style>
+        <p:txBody>
+          <a:bodyPr rtlCol="0" anchor="ctr"/>
+          <a:lstStyle/>
+          <a:p>
+            <a:pPr algn="ctr"/>
+            <a:endParaRPr lang="ru-RU"/>
+          </a:p>
+        </p:txBody>
+      </p:sp>
+      <p:sp>
+        <p:nvSpPr>
+          <p:cNvPr id="37" name="TextBox 36"/>
+          <p:cNvSpPr txBox="1"/>
+          <p:nvPr/>
+        </p:nvSpPr>
+        <p:spPr>
+          <a:xfrm>
+            <a:off x="2616200" y="5880100"/>
+            <a:ext cx="1168400" cy="369332"/>
+          </a:xfrm>
+          <a:prstGeom prst="rect">
+            <a:avLst/>
+          </a:prstGeom>
+          <a:noFill/>
+        </p:spPr>
+        <p:txBody>
+          <a:bodyPr vert="horz" wrap="square" lIns="0" tIns="0" rIns="0" bIns="0" rtlCol="0" anchor="ctr">
+            <a:noAutofit/>
+          </a:bodyPr>
+          <a:lstStyle/>
+          <a:p>
+            <a:pPr algn="ctr"/>
             <a:r>
               <a:rPr lang="en-US" sz="1000" b="1" smtClean="0">
                 <a:solidFill>
@@ -4818,7 +4871,7 @@
                 </a:solidFill>
                 <a:latin typeface="Segoe UI"/>
               </a:rPr>
-              <a:t>Optional distractor: ne eto ishchem</a:t>
+              <a:t>Q-07</a:t>
             </a:r>
             <a:endParaRPr lang="ru-RU" sz="1000" b="1">
               <a:solidFill>
@@ -4829,10 +4882,50 @@
           </a:p>
         </p:txBody>
       </p:sp>
+      <p:sp>
+        <p:nvSpPr>
+          <p:cNvPr id="38" name="TextBox 37"/>
+          <p:cNvSpPr txBox="1"/>
+          <p:nvPr/>
+        </p:nvSpPr>
+        <p:spPr>
+          <a:xfrm>
+            <a:off x="3937000" y="5880100"/>
+            <a:ext cx="5588000" cy="369332"/>
+          </a:xfrm>
+          <a:prstGeom prst="rect">
+            <a:avLst/>
+          </a:prstGeom>
+          <a:noFill/>
+        </p:spPr>
+        <p:txBody>
+          <a:bodyPr vert="horz" wrap="square" lIns="0" tIns="0" rIns="0" bIns="0" rtlCol="0" anchor="ctr">
+            <a:noAutofit/>
+          </a:bodyPr>
+          <a:lstStyle/>
+          <a:p>
+            <a:r>
+              <a:rPr lang="en-US" sz="1100" b="1" smtClean="0">
+                <a:solidFill>
+                  <a:srgbClr val="7A4A1A"/>
+                </a:solidFill>
+                <a:latin typeface="Segoe UI"/>
+              </a:rPr>
+              <a:t>Ne putat rabochuyu ploshchadku so svyazyami i krepleniem.</a:t>
+            </a:r>
+            <a:endParaRPr lang="ru-RU" sz="1100" b="1">
+              <a:solidFill>
+                <a:srgbClr val="7A4A1A"/>
+              </a:solidFill>
+              <a:latin typeface="Segoe UI"/>
+            </a:endParaRPr>
+          </a:p>
+        </p:txBody>
+      </p:sp>
     </p:spTree>
     <p:extLst>
       <p:ext uri="{BB962C8B-B14F-4D97-AF65-F5344CB8AC3E}">
-        <p14:creationId xmlns:p14="http://schemas.microsoft.com/office/powerpoint/2010/main" val="2297729726"/>
+        <p14:creationId xmlns:p14="http://schemas.microsoft.com/office/powerpoint/2010/main" val="834886335"/>
       </p:ext>
     </p:extLst>
   </p:cSld>
@@ -5114,7 +5207,7 @@
         </p:nvSpPr>
         <p:spPr>
           <a:xfrm>
-            <a:off x="609600" y="1447800"/>
+            <a:off x="638519" y="1447800"/>
             <a:ext cx="10414000" cy="369332"/>
           </a:xfrm>
           <a:prstGeom prst="rect">
@@ -5129,15 +5222,195 @@
           <a:lstStyle/>
           <a:p>
             <a:r>
-              <a:rPr lang="en-US" sz="1300" smtClean="0">
+              <a:rPr lang="en-US" sz="1400" dirty="0" smtClean="0">
                 <a:solidFill>
                   <a:srgbClr val="445465"/>
                 </a:solidFill>
                 <a:latin typeface="Segoe UI"/>
               </a:rPr>
-              <a:t>Visual nuzhen ne dlya 'pochti godno', a dlya mgnovennogo resheniya po priemke elementa.</a:t>
-            </a:r>
-            <a:endParaRPr lang="ru-RU" sz="1300">
+              <a:t>Visual </a:t>
+            </a:r>
+            <a:r>
+              <a:rPr lang="en-US" sz="1400" dirty="0" err="1" smtClean="0">
+                <a:solidFill>
+                  <a:srgbClr val="445465"/>
+                </a:solidFill>
+                <a:latin typeface="Segoe UI"/>
+              </a:rPr>
+              <a:t>nuzhen</a:t>
+            </a:r>
+            <a:r>
+              <a:rPr lang="en-US" sz="1400" dirty="0" smtClean="0">
+                <a:solidFill>
+                  <a:srgbClr val="445465"/>
+                </a:solidFill>
+                <a:latin typeface="Segoe UI"/>
+              </a:rPr>
+              <a:t> ne </a:t>
+            </a:r>
+            <a:r>
+              <a:rPr lang="en-US" sz="1400" dirty="0" err="1" smtClean="0">
+                <a:solidFill>
+                  <a:srgbClr val="445465"/>
+                </a:solidFill>
+                <a:latin typeface="Segoe UI"/>
+              </a:rPr>
+              <a:t>dlya</a:t>
+            </a:r>
+            <a:r>
+              <a:rPr lang="en-US" sz="1400" dirty="0" smtClean="0">
+                <a:solidFill>
+                  <a:srgbClr val="445465"/>
+                </a:solidFill>
+                <a:latin typeface="Segoe UI"/>
+              </a:rPr>
+              <a:t> '</a:t>
+            </a:r>
+            <a:r>
+              <a:rPr lang="en-US" sz="1400" dirty="0" err="1" smtClean="0">
+                <a:solidFill>
+                  <a:srgbClr val="445465"/>
+                </a:solidFill>
+                <a:latin typeface="Segoe UI"/>
+              </a:rPr>
+              <a:t>pochti</a:t>
+            </a:r>
+            <a:r>
+              <a:rPr lang="en-US" sz="1400" dirty="0" smtClean="0">
+                <a:solidFill>
+                  <a:srgbClr val="445465"/>
+                </a:solidFill>
+                <a:latin typeface="Segoe UI"/>
+              </a:rPr>
+              <a:t> </a:t>
+            </a:r>
+            <a:r>
+              <a:rPr lang="en-US" sz="1400" dirty="0" err="1" smtClean="0">
+                <a:solidFill>
+                  <a:srgbClr val="445465"/>
+                </a:solidFill>
+                <a:latin typeface="Segoe UI"/>
+              </a:rPr>
+              <a:t>godno</a:t>
+            </a:r>
+            <a:r>
+              <a:rPr lang="en-US" sz="1400" dirty="0" smtClean="0">
+                <a:solidFill>
+                  <a:srgbClr val="445465"/>
+                </a:solidFill>
+                <a:latin typeface="Segoe UI"/>
+              </a:rPr>
+              <a:t>', a </a:t>
+            </a:r>
+            <a:r>
+              <a:rPr lang="en-US" sz="1400" dirty="0" err="1" smtClean="0">
+                <a:solidFill>
+                  <a:srgbClr val="445465"/>
+                </a:solidFill>
+                <a:latin typeface="Segoe UI"/>
+              </a:rPr>
+              <a:t>dlya</a:t>
+            </a:r>
+            <a:r>
+              <a:rPr lang="en-US" sz="1400" dirty="0" smtClean="0">
+                <a:solidFill>
+                  <a:srgbClr val="445465"/>
+                </a:solidFill>
+                <a:latin typeface="Segoe UI"/>
+              </a:rPr>
+              <a:t> </a:t>
+            </a:r>
+            <a:r>
+              <a:rPr lang="en-US" sz="1400" dirty="0" err="1" smtClean="0">
+                <a:solidFill>
+                  <a:srgbClr val="445465"/>
+                </a:solidFill>
+                <a:latin typeface="Segoe UI"/>
+              </a:rPr>
+              <a:t>mgnovennogo</a:t>
+            </a:r>
+            <a:r>
+              <a:rPr lang="en-US" sz="1400" dirty="0" smtClean="0">
+                <a:solidFill>
+                  <a:srgbClr val="445465"/>
+                </a:solidFill>
+                <a:latin typeface="Segoe UI"/>
+              </a:rPr>
+              <a:t> </a:t>
+            </a:r>
+            <a:r>
+              <a:rPr lang="en-US" sz="1400" dirty="0" err="1" smtClean="0">
+                <a:solidFill>
+                  <a:srgbClr val="445465"/>
+                </a:solidFill>
+                <a:latin typeface="Segoe UI"/>
+              </a:rPr>
+              <a:t>resheniya</a:t>
+            </a:r>
+            <a:r>
+              <a:rPr lang="en-US" sz="1400" dirty="0" smtClean="0">
+                <a:solidFill>
+                  <a:srgbClr val="445465"/>
+                </a:solidFill>
+                <a:latin typeface="Segoe UI"/>
+              </a:rPr>
+              <a:t> </a:t>
+            </a:r>
+            <a:r>
+              <a:rPr lang="en-US" sz="1400" dirty="0" err="1" smtClean="0">
+                <a:solidFill>
+                  <a:srgbClr val="445465"/>
+                </a:solidFill>
+                <a:latin typeface="Segoe UI"/>
+              </a:rPr>
+              <a:t>po</a:t>
+            </a:r>
+            <a:r>
+              <a:rPr lang="en-US" sz="1400" dirty="0" smtClean="0">
+                <a:solidFill>
+                  <a:srgbClr val="445465"/>
+                </a:solidFill>
+                <a:latin typeface="Segoe UI"/>
+              </a:rPr>
+              <a:t> </a:t>
+            </a:r>
+            <a:r>
+              <a:rPr lang="en-US" sz="1400" dirty="0" err="1" smtClean="0">
+                <a:solidFill>
+                  <a:srgbClr val="445465"/>
+                </a:solidFill>
+                <a:latin typeface="Segoe UI"/>
+              </a:rPr>
+              <a:t>priemke</a:t>
+            </a:r>
+            <a:r>
+              <a:rPr lang="en-US" sz="1400" dirty="0" smtClean="0">
+                <a:solidFill>
+                  <a:srgbClr val="445465"/>
+                </a:solidFill>
+                <a:latin typeface="Segoe UI"/>
+              </a:rPr>
+              <a:t> </a:t>
+            </a:r>
+            <a:r>
+              <a:rPr lang="en-US" sz="1400" dirty="0" err="1" smtClean="0">
+                <a:solidFill>
+                  <a:srgbClr val="445465"/>
+                </a:solidFill>
+                <a:latin typeface="Segoe UI"/>
+              </a:rPr>
+              <a:t>elementa</a:t>
+            </a:r>
+            <a:r>
+              <a:rPr lang="en-US" sz="1400" dirty="0" smtClean="0">
+                <a:solidFill>
+                  <a:srgbClr val="445465"/>
+                </a:solidFill>
+                <a:latin typeface="Segoe UI"/>
+              </a:rPr>
+              <a:t>.</a:t>
+            </a:r>
+            <a:endParaRPr lang="ru-RU" sz="1400" dirty="0">
               <a:solidFill>
                 <a:srgbClr val="445465"/>
               </a:solidFill>
@@ -5155,7 +5428,7 @@
         <p:spPr>
           <a:xfrm>
             <a:off x="609600" y="1930400"/>
-            <a:ext cx="4445000" cy="304800"/>
+            <a:ext cx="4445000" cy="490488"/>
           </a:xfrm>
           <a:prstGeom prst="roundRect">
             <a:avLst>
@@ -5224,15 +5497,114 @@
           <a:p>
             <a:pPr algn="ctr"/>
             <a:r>
-              <a:rPr lang="en-US" sz="1000" b="1" smtClean="0">
+              <a:rPr lang="en-US" sz="1400" b="1" dirty="0" smtClean="0">
                 <a:solidFill>
                   <a:srgbClr val="FFFFFF"/>
                 </a:solidFill>
                 <a:latin typeface="Segoe UI"/>
               </a:rPr>
-              <a:t>Test prompt: kakoy element nado srazu vyvesti iz sborki</a:t>
-            </a:r>
-            <a:endParaRPr lang="ru-RU" sz="1000" b="1">
+              <a:t>Test prompt: </a:t>
+            </a:r>
+            <a:r>
+              <a:rPr lang="en-US" sz="1400" b="1" dirty="0" err="1" smtClean="0">
+                <a:solidFill>
+                  <a:srgbClr val="FFFFFF"/>
+                </a:solidFill>
+                <a:latin typeface="Segoe UI"/>
+              </a:rPr>
+              <a:t>kakoy</a:t>
+            </a:r>
+            <a:r>
+              <a:rPr lang="en-US" sz="1400" b="1" dirty="0" smtClean="0">
+                <a:solidFill>
+                  <a:srgbClr val="FFFFFF"/>
+                </a:solidFill>
+                <a:latin typeface="Segoe UI"/>
+              </a:rPr>
+              <a:t> element </a:t>
+            </a:r>
+            <a:r>
+              <a:rPr lang="en-US" sz="1400" b="1" dirty="0" err="1" smtClean="0">
+                <a:solidFill>
+                  <a:srgbClr val="FFFFFF"/>
+                </a:solidFill>
+                <a:latin typeface="Segoe UI"/>
+              </a:rPr>
+              <a:t>nado</a:t>
+            </a:r>
+            <a:r>
+              <a:rPr lang="en-US" sz="1400" b="1" dirty="0" smtClean="0">
+                <a:solidFill>
+                  <a:srgbClr val="FFFFFF"/>
+                </a:solidFill>
+                <a:latin typeface="Segoe UI"/>
+              </a:rPr>
+              <a:t> </a:t>
+            </a:r>
+            <a:r>
+              <a:rPr lang="en-US" sz="1400" b="1" dirty="0" err="1" smtClean="0">
+                <a:solidFill>
+                  <a:srgbClr val="FFFFFF"/>
+                </a:solidFill>
+                <a:latin typeface="Segoe UI"/>
+              </a:rPr>
+              <a:t>srazu</a:t>
+            </a:r>
+            <a:r>
+              <a:rPr lang="en-US" sz="1400" b="1" dirty="0" smtClean="0">
+                <a:solidFill>
+                  <a:srgbClr val="FFFFFF"/>
+                </a:solidFill>
+                <a:latin typeface="Segoe UI"/>
+              </a:rPr>
+              <a:t> </a:t>
+            </a:r>
+            <a:r>
+              <a:rPr lang="en-US" sz="1400" b="1" dirty="0" err="1" smtClean="0">
+                <a:solidFill>
+                  <a:srgbClr val="FFFFFF"/>
+                </a:solidFill>
+                <a:latin typeface="Segoe UI"/>
+              </a:rPr>
+              <a:t>vyvesti</a:t>
+            </a:r>
+            <a:r>
+              <a:rPr lang="en-US" sz="1400" b="1" dirty="0" smtClean="0">
+                <a:solidFill>
+                  <a:srgbClr val="FFFFFF"/>
+                </a:solidFill>
+                <a:latin typeface="Segoe UI"/>
+              </a:rPr>
+              <a:t> </a:t>
+            </a:r>
+            <a:r>
+              <a:rPr lang="en-US" sz="1400" b="1" dirty="0" err="1" smtClean="0">
+                <a:solidFill>
+                  <a:srgbClr val="FFFFFF"/>
+                </a:solidFill>
+                <a:latin typeface="Segoe UI"/>
+              </a:rPr>
+              <a:t>iz</a:t>
+            </a:r>
+            <a:r>
+              <a:rPr lang="en-US" sz="1400" b="1" dirty="0" smtClean="0">
+                <a:solidFill>
+                  <a:srgbClr val="FFFFFF"/>
+                </a:solidFill>
+                <a:latin typeface="Segoe UI"/>
+              </a:rPr>
+              <a:t> </a:t>
+            </a:r>
+            <a:r>
+              <a:rPr lang="en-US" sz="1400" b="1" dirty="0" err="1" smtClean="0">
+                <a:solidFill>
+                  <a:srgbClr val="FFFFFF"/>
+                </a:solidFill>
+                <a:latin typeface="Segoe UI"/>
+              </a:rPr>
+              <a:t>sborki</a:t>
+            </a:r>
+            <a:endParaRPr lang="ru-RU" sz="1400" b="1" dirty="0">
               <a:solidFill>
                 <a:srgbClr val="FFFFFF"/>
               </a:solidFill>
@@ -5527,8 +5899,8 @@
         </p:nvSpPr>
         <p:spPr>
           <a:xfrm>
-            <a:off x="1092200" y="2794000"/>
-            <a:ext cx="1320800" cy="369332"/>
+            <a:off x="1124139" y="2549778"/>
+            <a:ext cx="1320800" cy="717044"/>
           </a:xfrm>
           <a:prstGeom prst="rect">
             <a:avLst/>
@@ -5543,7 +5915,7 @@
           <a:p>
             <a:pPr algn="ctr"/>
             <a:r>
-              <a:rPr lang="en-US" sz="1000" b="1" smtClean="0">
+              <a:rPr lang="en-US" sz="2000" b="1" dirty="0" smtClean="0">
                 <a:solidFill>
                   <a:srgbClr val="FFFFFF"/>
                 </a:solidFill>
@@ -5551,7 +5923,7 @@
               </a:rPr>
               <a:t>GOOD</a:t>
             </a:r>
-            <a:endParaRPr lang="ru-RU" sz="1000" b="1">
+            <a:endParaRPr lang="ru-RU" sz="2000" b="1" dirty="0">
               <a:solidFill>
                 <a:srgbClr val="FFFFFF"/>
               </a:solidFill>
@@ -5683,15 +6055,78 @@
           <a:lstStyle/>
           <a:p>
             <a:r>
-              <a:rPr lang="en-US" sz="1120" smtClean="0">
+              <a:rPr lang="en-US" sz="1400" dirty="0" err="1" smtClean="0">
                 <a:solidFill>
                   <a:srgbClr val="445465"/>
                 </a:solidFill>
                 <a:latin typeface="Segoe UI"/>
               </a:rPr>
-              <a:t>bez deformatsii i slomannykh konturov</a:t>
-            </a:r>
-            <a:endParaRPr lang="ru-RU" sz="1120">
+              <a:t>bez</a:t>
+            </a:r>
+            <a:r>
+              <a:rPr lang="en-US" sz="1400" dirty="0" smtClean="0">
+                <a:solidFill>
+                  <a:srgbClr val="445465"/>
+                </a:solidFill>
+                <a:latin typeface="Segoe UI"/>
+              </a:rPr>
+              <a:t> </a:t>
+            </a:r>
+            <a:r>
+              <a:rPr lang="en-US" sz="1400" dirty="0" err="1" smtClean="0">
+                <a:solidFill>
+                  <a:srgbClr val="445465"/>
+                </a:solidFill>
+                <a:latin typeface="Segoe UI"/>
+              </a:rPr>
+              <a:t>deformatsii</a:t>
+            </a:r>
+            <a:r>
+              <a:rPr lang="en-US" sz="1400" dirty="0" smtClean="0">
+                <a:solidFill>
+                  <a:srgbClr val="445465"/>
+                </a:solidFill>
+                <a:latin typeface="Segoe UI"/>
+              </a:rPr>
+              <a:t> i </a:t>
+            </a:r>
+            <a:r>
+              <a:rPr lang="en-US" sz="1400" dirty="0" err="1" smtClean="0">
+                <a:solidFill>
+                  <a:srgbClr val="445465"/>
+                </a:solidFill>
+                <a:latin typeface="Segoe UI"/>
+              </a:rPr>
+              <a:t>slomannykh</a:t>
+            </a:r>
+            <a:r>
+              <a:rPr lang="en-US" sz="1400" dirty="0" smtClean="0">
+                <a:solidFill>
+                  <a:srgbClr val="445465"/>
+                </a:solidFill>
+                <a:latin typeface="Segoe UI"/>
+              </a:rPr>
+              <a:t> </a:t>
+            </a:r>
+            <a:r>
+              <a:rPr lang="en-US" sz="1400" dirty="0" err="1" smtClean="0">
+                <a:solidFill>
+                  <a:srgbClr val="445465"/>
+                </a:solidFill>
+                <a:latin typeface="Segoe UI"/>
+              </a:rPr>
+              <a:t>konturo</a:t>
+            </a:r>
+            <a:r>
+              <a:rPr lang="en-US" sz="1120" dirty="0" err="1" smtClean="0">
+                <a:solidFill>
+                  <a:srgbClr val="445465"/>
+                </a:solidFill>
+                <a:latin typeface="Segoe UI"/>
+              </a:rPr>
+              <a:t>v</a:t>
+            </a:r>
+            <a:endParaRPr lang="ru-RU" sz="1120" dirty="0">
               <a:solidFill>
                 <a:srgbClr val="445465"/>
               </a:solidFill>
@@ -5783,15 +6218,87 @@
           <a:lstStyle/>
           <a:p>
             <a:r>
-              <a:rPr lang="en-US" sz="1120" smtClean="0">
+              <a:rPr lang="en-US" sz="1400" dirty="0" err="1" smtClean="0">
                 <a:solidFill>
                   <a:srgbClr val="445465"/>
                 </a:solidFill>
                 <a:latin typeface="Segoe UI"/>
               </a:rPr>
-              <a:t>komplektnyy uzel bez yavnykh propuskov</a:t>
-            </a:r>
-            <a:endParaRPr lang="ru-RU" sz="1120">
+              <a:t>komplektnyy</a:t>
+            </a:r>
+            <a:r>
+              <a:rPr lang="en-US" sz="1400" dirty="0" smtClean="0">
+                <a:solidFill>
+                  <a:srgbClr val="445465"/>
+                </a:solidFill>
+                <a:latin typeface="Segoe UI"/>
+              </a:rPr>
+              <a:t> </a:t>
+            </a:r>
+            <a:r>
+              <a:rPr lang="en-US" sz="1400" dirty="0" err="1" smtClean="0">
+                <a:solidFill>
+                  <a:srgbClr val="445465"/>
+                </a:solidFill>
+                <a:latin typeface="Segoe UI"/>
+              </a:rPr>
+              <a:t>uzel</a:t>
+            </a:r>
+            <a:r>
+              <a:rPr lang="en-US" sz="1400" dirty="0" smtClean="0">
+                <a:solidFill>
+                  <a:srgbClr val="445465"/>
+                </a:solidFill>
+                <a:latin typeface="Segoe UI"/>
+              </a:rPr>
+              <a:t> </a:t>
+            </a:r>
+            <a:r>
+              <a:rPr lang="en-US" sz="1400" dirty="0" err="1" smtClean="0">
+                <a:solidFill>
+                  <a:srgbClr val="445465"/>
+                </a:solidFill>
+                <a:latin typeface="Segoe UI"/>
+              </a:rPr>
+              <a:t>bez</a:t>
+            </a:r>
+            <a:r>
+              <a:rPr lang="en-US" sz="1400" dirty="0" smtClean="0">
+                <a:solidFill>
+                  <a:srgbClr val="445465"/>
+                </a:solidFill>
+                <a:latin typeface="Segoe UI"/>
+              </a:rPr>
+              <a:t> </a:t>
+            </a:r>
+            <a:r>
+              <a:rPr lang="en-US" sz="1400" dirty="0" err="1" smtClean="0">
+                <a:solidFill>
+                  <a:srgbClr val="445465"/>
+                </a:solidFill>
+                <a:latin typeface="Segoe UI"/>
+              </a:rPr>
+              <a:t>yavnykh</a:t>
+            </a:r>
+            <a:r>
+              <a:rPr lang="en-US" sz="1400" dirty="0" smtClean="0">
+                <a:solidFill>
+                  <a:srgbClr val="445465"/>
+                </a:solidFill>
+                <a:latin typeface="Segoe UI"/>
+              </a:rPr>
+              <a:t> </a:t>
+            </a:r>
+            <a:r>
+              <a:rPr lang="en-US" sz="1400" dirty="0" err="1" smtClean="0">
+                <a:solidFill>
+                  <a:srgbClr val="445465"/>
+                </a:solidFill>
+                <a:latin typeface="Segoe UI"/>
+              </a:rPr>
+              <a:t>propuskov</a:t>
+            </a:r>
+            <a:endParaRPr lang="ru-RU" sz="1400" dirty="0">
               <a:solidFill>
                 <a:srgbClr val="445465"/>
               </a:solidFill>
@@ -5883,7 +6390,7 @@
           <a:lstStyle/>
           <a:p>
             <a:r>
-              <a:rPr lang="it-IT" sz="1120" smtClean="0">
+              <a:rPr lang="it-IT" sz="1400" dirty="0" smtClean="0">
                 <a:solidFill>
                   <a:srgbClr val="445465"/>
                 </a:solidFill>
@@ -5891,7 +6398,7 @@
               </a:rPr>
               <a:t>rabochiy vid, a ne 'idealnaya vitrinna'</a:t>
             </a:r>
-            <a:endParaRPr lang="ru-RU" sz="1120">
+            <a:endParaRPr lang="ru-RU" sz="1400" dirty="0">
               <a:solidFill>
                 <a:srgbClr val="445465"/>
               </a:solidFill>
@@ -5923,15 +6430,42 @@
           <a:lstStyle/>
           <a:p>
             <a:r>
-              <a:rPr lang="en-US" sz="1040" b="1" smtClean="0">
+              <a:rPr lang="en-US" sz="1400" b="1" dirty="0" err="1" smtClean="0">
                 <a:solidFill>
                   <a:srgbClr val="6A7782"/>
                 </a:solidFill>
                 <a:latin typeface="Segoe UI"/>
               </a:rPr>
-              <a:t>Neutralnyy rabochiy etalon</a:t>
-            </a:r>
-            <a:endParaRPr lang="ru-RU" sz="1040" b="1">
+              <a:t>Neutralnyy</a:t>
+            </a:r>
+            <a:r>
+              <a:rPr lang="en-US" sz="1400" b="1" dirty="0" smtClean="0">
+                <a:solidFill>
+                  <a:srgbClr val="6A7782"/>
+                </a:solidFill>
+                <a:latin typeface="Segoe UI"/>
+              </a:rPr>
+              <a:t> </a:t>
+            </a:r>
+            <a:r>
+              <a:rPr lang="en-US" sz="1400" b="1" dirty="0" err="1" smtClean="0">
+                <a:solidFill>
+                  <a:srgbClr val="6A7782"/>
+                </a:solidFill>
+                <a:latin typeface="Segoe UI"/>
+              </a:rPr>
+              <a:t>rabochiy</a:t>
+            </a:r>
+            <a:r>
+              <a:rPr lang="en-US" sz="1400" b="1" dirty="0" smtClean="0">
+                <a:solidFill>
+                  <a:srgbClr val="6A7782"/>
+                </a:solidFill>
+                <a:latin typeface="Segoe UI"/>
+              </a:rPr>
+              <a:t> etalon</a:t>
+            </a:r>
+            <a:endParaRPr lang="ru-RU" sz="1400" b="1" dirty="0">
               <a:solidFill>
                 <a:srgbClr val="6A7782"/>
               </a:solidFill>
@@ -6056,7 +6590,7 @@
         </p:nvSpPr>
         <p:spPr>
           <a:xfrm>
-            <a:off x="6934200" y="2794000"/>
+            <a:off x="6934200" y="2723634"/>
             <a:ext cx="1320800" cy="369332"/>
           </a:xfrm>
           <a:prstGeom prst="rect">
@@ -6072,7 +6606,7 @@
           <a:p>
             <a:pPr algn="ctr"/>
             <a:r>
-              <a:rPr lang="en-US" sz="1000" b="1" smtClean="0">
+              <a:rPr lang="en-US" sz="2000" b="1" smtClean="0">
                 <a:solidFill>
                   <a:srgbClr val="FFFFFF"/>
                 </a:solidFill>
@@ -6080,7 +6614,7 @@
               </a:rPr>
               <a:t>NO-GO</a:t>
             </a:r>
-            <a:endParaRPr lang="ru-RU" sz="1000" b="1">
+            <a:endParaRPr lang="ru-RU" sz="2000" b="1">
               <a:solidFill>
                 <a:srgbClr val="FFFFFF"/>
               </a:solidFill>
@@ -6212,15 +6746,69 @@
           <a:lstStyle/>
           <a:p>
             <a:r>
-              <a:rPr lang="en-US" sz="1120" smtClean="0">
+              <a:rPr lang="en-US" sz="1400" dirty="0" err="1" smtClean="0">
                 <a:solidFill>
                   <a:srgbClr val="445465"/>
                 </a:solidFill>
                 <a:latin typeface="Segoe UI"/>
               </a:rPr>
-              <a:t>deformatsiya ili yavnoe iskrivlenie</a:t>
-            </a:r>
-            <a:endParaRPr lang="ru-RU" sz="1120">
+              <a:t>deformatsiya</a:t>
+            </a:r>
+            <a:r>
+              <a:rPr lang="en-US" sz="1400" dirty="0" smtClean="0">
+                <a:solidFill>
+                  <a:srgbClr val="445465"/>
+                </a:solidFill>
+                <a:latin typeface="Segoe UI"/>
+              </a:rPr>
+              <a:t> </a:t>
+            </a:r>
+            <a:r>
+              <a:rPr lang="en-US" sz="1400" dirty="0" err="1" smtClean="0">
+                <a:solidFill>
+                  <a:srgbClr val="445465"/>
+                </a:solidFill>
+                <a:latin typeface="Segoe UI"/>
+              </a:rPr>
+              <a:t>ili</a:t>
+            </a:r>
+            <a:r>
+              <a:rPr lang="en-US" sz="1400" dirty="0" smtClean="0">
+                <a:solidFill>
+                  <a:srgbClr val="445465"/>
+                </a:solidFill>
+                <a:latin typeface="Segoe UI"/>
+              </a:rPr>
+              <a:t> </a:t>
+            </a:r>
+            <a:r>
+              <a:rPr lang="en-US" sz="1400" dirty="0" err="1" smtClean="0">
+                <a:solidFill>
+                  <a:srgbClr val="445465"/>
+                </a:solidFill>
+                <a:latin typeface="Segoe UI"/>
+              </a:rPr>
+              <a:t>yavnoe</a:t>
+            </a:r>
+            <a:r>
+              <a:rPr lang="en-US" sz="1400" dirty="0" smtClean="0">
+                <a:solidFill>
+                  <a:srgbClr val="445465"/>
+                </a:solidFill>
+                <a:latin typeface="Segoe UI"/>
+              </a:rPr>
+              <a:t> </a:t>
+            </a:r>
+            <a:r>
+              <a:rPr lang="en-US" sz="1400" dirty="0" err="1" smtClean="0">
+                <a:solidFill>
+                  <a:srgbClr val="445465"/>
+                </a:solidFill>
+                <a:latin typeface="Segoe UI"/>
+              </a:rPr>
+              <a:t>iskrivlenie</a:t>
+            </a:r>
+            <a:endParaRPr lang="ru-RU" sz="1400" dirty="0">
               <a:solidFill>
                 <a:srgbClr val="445465"/>
               </a:solidFill>
@@ -6312,15 +6900,69 @@
           <a:lstStyle/>
           <a:p>
             <a:r>
-              <a:rPr lang="en-US" sz="1120" smtClean="0">
+              <a:rPr lang="en-US" sz="1400" dirty="0" err="1" smtClean="0">
                 <a:solidFill>
                   <a:srgbClr val="445465"/>
                 </a:solidFill>
                 <a:latin typeface="Segoe UI"/>
               </a:rPr>
-              <a:t>nekomplektnyy ili povrezhdennyy uzel</a:t>
-            </a:r>
-            <a:endParaRPr lang="ru-RU" sz="1120">
+              <a:t>nekomplektnyy</a:t>
+            </a:r>
+            <a:r>
+              <a:rPr lang="en-US" sz="1400" dirty="0" smtClean="0">
+                <a:solidFill>
+                  <a:srgbClr val="445465"/>
+                </a:solidFill>
+                <a:latin typeface="Segoe UI"/>
+              </a:rPr>
+              <a:t> </a:t>
+            </a:r>
+            <a:r>
+              <a:rPr lang="en-US" sz="1400" dirty="0" err="1" smtClean="0">
+                <a:solidFill>
+                  <a:srgbClr val="445465"/>
+                </a:solidFill>
+                <a:latin typeface="Segoe UI"/>
+              </a:rPr>
+              <a:t>ili</a:t>
+            </a:r>
+            <a:r>
+              <a:rPr lang="en-US" sz="1400" dirty="0" smtClean="0">
+                <a:solidFill>
+                  <a:srgbClr val="445465"/>
+                </a:solidFill>
+                <a:latin typeface="Segoe UI"/>
+              </a:rPr>
+              <a:t> </a:t>
+            </a:r>
+            <a:r>
+              <a:rPr lang="en-US" sz="1400" dirty="0" err="1" smtClean="0">
+                <a:solidFill>
+                  <a:srgbClr val="445465"/>
+                </a:solidFill>
+                <a:latin typeface="Segoe UI"/>
+              </a:rPr>
+              <a:t>povrezhdennyy</a:t>
+            </a:r>
+            <a:r>
+              <a:rPr lang="en-US" sz="1400" dirty="0" smtClean="0">
+                <a:solidFill>
+                  <a:srgbClr val="445465"/>
+                </a:solidFill>
+                <a:latin typeface="Segoe UI"/>
+              </a:rPr>
+              <a:t> </a:t>
+            </a:r>
+            <a:r>
+              <a:rPr lang="en-US" sz="1400" dirty="0" err="1" smtClean="0">
+                <a:solidFill>
+                  <a:srgbClr val="445465"/>
+                </a:solidFill>
+                <a:latin typeface="Segoe UI"/>
+              </a:rPr>
+              <a:t>uzel</a:t>
+            </a:r>
+            <a:endParaRPr lang="ru-RU" sz="1400" dirty="0">
               <a:solidFill>
                 <a:srgbClr val="445465"/>
               </a:solidFill>
@@ -6412,15 +7054,78 @@
           <a:lstStyle/>
           <a:p>
             <a:r>
-              <a:rPr lang="en-US" sz="1120" smtClean="0">
+              <a:rPr lang="en-US" sz="1400" dirty="0" smtClean="0">
                 <a:solidFill>
                   <a:srgbClr val="445465"/>
                 </a:solidFill>
                 <a:latin typeface="Segoe UI"/>
               </a:rPr>
-              <a:t>element srazu vyvoditsya iz sborki</a:t>
-            </a:r>
-            <a:endParaRPr lang="ru-RU" sz="1120">
+              <a:t>element </a:t>
+            </a:r>
+            <a:r>
+              <a:rPr lang="en-US" sz="1400" dirty="0" err="1" smtClean="0">
+                <a:solidFill>
+                  <a:srgbClr val="445465"/>
+                </a:solidFill>
+                <a:latin typeface="Segoe UI"/>
+              </a:rPr>
+              <a:t>srazu</a:t>
+            </a:r>
+            <a:r>
+              <a:rPr lang="en-US" sz="1400" dirty="0" smtClean="0">
+                <a:solidFill>
+                  <a:srgbClr val="445465"/>
+                </a:solidFill>
+                <a:latin typeface="Segoe UI"/>
+              </a:rPr>
+              <a:t> </a:t>
+            </a:r>
+            <a:r>
+              <a:rPr lang="en-US" sz="1400" dirty="0" err="1" smtClean="0">
+                <a:solidFill>
+                  <a:srgbClr val="445465"/>
+                </a:solidFill>
+                <a:latin typeface="Segoe UI"/>
+              </a:rPr>
+              <a:t>vyvoditsya</a:t>
+            </a:r>
+            <a:r>
+              <a:rPr lang="en-US" sz="1400" dirty="0" smtClean="0">
+                <a:solidFill>
+                  <a:srgbClr val="445465"/>
+                </a:solidFill>
+                <a:latin typeface="Segoe UI"/>
+              </a:rPr>
+              <a:t> </a:t>
+            </a:r>
+            <a:r>
+              <a:rPr lang="en-US" sz="1400" dirty="0" err="1" smtClean="0">
+                <a:solidFill>
+                  <a:srgbClr val="445465"/>
+                </a:solidFill>
+                <a:latin typeface="Segoe UI"/>
+              </a:rPr>
+              <a:t>iz</a:t>
+            </a:r>
+            <a:r>
+              <a:rPr lang="en-US" sz="1400" dirty="0" smtClean="0">
+                <a:solidFill>
+                  <a:srgbClr val="445465"/>
+                </a:solidFill>
+                <a:latin typeface="Segoe UI"/>
+              </a:rPr>
+              <a:t> </a:t>
+            </a:r>
+            <a:r>
+              <a:rPr lang="en-US" sz="1400" dirty="0" err="1" smtClean="0">
+                <a:solidFill>
+                  <a:srgbClr val="445465"/>
+                </a:solidFill>
+                <a:latin typeface="Segoe UI"/>
+              </a:rPr>
+              <a:t>sborki</a:t>
+            </a:r>
+            <a:endParaRPr lang="ru-RU" sz="1400" dirty="0">
               <a:solidFill>
                 <a:srgbClr val="445465"/>
               </a:solidFill>
@@ -6452,7 +7157,7 @@
           <a:lstStyle/>
           <a:p>
             <a:r>
-              <a:rPr lang="pl-PL" sz="1040" b="1" smtClean="0">
+              <a:rPr lang="pl-PL" sz="1400" b="1" dirty="0" smtClean="0">
                 <a:solidFill>
                   <a:srgbClr val="6A7782"/>
                 </a:solidFill>
@@ -6460,7 +7165,7 @@
               </a:rPr>
               <a:t>Ne 'pochti godno', a srazu v brak / otbor</a:t>
             </a:r>
-            <a:endParaRPr lang="ru-RU" sz="1040" b="1">
+            <a:endParaRPr lang="ru-RU" sz="1400" b="1" dirty="0">
               <a:solidFill>
                 <a:srgbClr val="6A7782"/>
               </a:solidFill>
@@ -6477,7 +7182,7 @@
         </p:nvCxnSpPr>
         <p:spPr>
           <a:xfrm>
-            <a:off x="5715000" y="4013200"/>
+            <a:off x="5715000" y="4541898"/>
             <a:ext cx="762000" cy="0"/>
           </a:xfrm>
           <a:prstGeom prst="line">
@@ -6513,7 +7218,7 @@
         </p:nvSpPr>
         <p:spPr>
           <a:xfrm>
-            <a:off x="5054600" y="3657600"/>
+            <a:off x="5359400" y="3619877"/>
             <a:ext cx="1473200" cy="304800"/>
           </a:xfrm>
           <a:prstGeom prst="roundRect">
@@ -6567,7 +7272,7 @@
         </p:nvSpPr>
         <p:spPr>
           <a:xfrm>
-            <a:off x="5054600" y="3683000"/>
+            <a:off x="5446917" y="3581400"/>
             <a:ext cx="1473200" cy="369332"/>
           </a:xfrm>
           <a:prstGeom prst="rect">
@@ -6583,15 +7288,33 @@
           <a:p>
             <a:pPr algn="ctr"/>
             <a:r>
-              <a:rPr lang="en-US" sz="1000" b="1" smtClean="0">
+              <a:rPr lang="en-US" sz="1400" b="1" dirty="0" err="1" smtClean="0">
                 <a:solidFill>
                   <a:srgbClr val="FFFFFF"/>
                 </a:solidFill>
                 <a:latin typeface="Segoe UI"/>
               </a:rPr>
-              <a:t>otbor do starta</a:t>
-            </a:r>
-            <a:endParaRPr lang="ru-RU" sz="1000" b="1">
+              <a:t>otbor</a:t>
+            </a:r>
+            <a:r>
+              <a:rPr lang="en-US" sz="1400" b="1" dirty="0" smtClean="0">
+                <a:solidFill>
+                  <a:srgbClr val="FFFFFF"/>
+                </a:solidFill>
+                <a:latin typeface="Segoe UI"/>
+              </a:rPr>
+              <a:t> do </a:t>
+            </a:r>
+            <a:r>
+              <a:rPr lang="en-US" sz="1400" b="1" dirty="0" err="1" smtClean="0">
+                <a:solidFill>
+                  <a:srgbClr val="FFFFFF"/>
+                </a:solidFill>
+                <a:latin typeface="Segoe UI"/>
+              </a:rPr>
+              <a:t>starta</a:t>
+            </a:r>
+            <a:endParaRPr lang="ru-RU" sz="1400" b="1" dirty="0">
               <a:solidFill>
                 <a:srgbClr val="FFFFFF"/>
               </a:solidFill>
@@ -6608,8 +7331,8 @@
         </p:nvSpPr>
         <p:spPr>
           <a:xfrm>
-            <a:off x="3429000" y="5638800"/>
-            <a:ext cx="5308600" cy="482600"/>
+            <a:off x="3302000" y="5588000"/>
+            <a:ext cx="5308600" cy="685800"/>
           </a:xfrm>
           <a:prstGeom prst="roundRect">
             <a:avLst>
@@ -6662,7 +7385,7 @@
         </p:nvSpPr>
         <p:spPr>
           <a:xfrm>
-            <a:off x="3581400" y="5803900"/>
+            <a:off x="3517900" y="5756521"/>
             <a:ext cx="127000" cy="127000"/>
           </a:xfrm>
           <a:prstGeom prst="ellipse">
@@ -6722,7 +7445,7 @@
         </p:nvSpPr>
         <p:spPr>
           <a:xfrm>
-            <a:off x="3784600" y="5740400"/>
+            <a:off x="3735774" y="5514189"/>
             <a:ext cx="4826000" cy="369332"/>
           </a:xfrm>
           <a:prstGeom prst="rect">
@@ -6737,7 +7460,7 @@
           <a:lstStyle/>
           <a:p>
             <a:r>
-              <a:rPr lang="en-US" sz="1250" b="1" smtClean="0">
+              <a:rPr lang="en-US" sz="1250" b="1" dirty="0" smtClean="0">
                 <a:solidFill>
                   <a:srgbClr val="17324D"/>
                 </a:solidFill>
@@ -6745,7 +7468,7 @@
               </a:rPr>
               <a:t>Q-08 support</a:t>
             </a:r>
-            <a:endParaRPr lang="ru-RU" sz="1250" b="1">
+            <a:endParaRPr lang="ru-RU" sz="1250" b="1" dirty="0">
               <a:solidFill>
                 <a:srgbClr val="17324D"/>
               </a:solidFill>
@@ -6762,7 +7485,7 @@
         </p:nvSpPr>
         <p:spPr>
           <a:xfrm>
-            <a:off x="3784600" y="6019800"/>
+            <a:off x="3718422" y="5793174"/>
             <a:ext cx="4826000" cy="369332"/>
           </a:xfrm>
           <a:prstGeom prst="rect">
@@ -6777,15 +7500,204 @@
           <a:lstStyle/>
           <a:p>
             <a:r>
-              <a:rPr lang="en-US" sz="1080" smtClean="0">
+              <a:rPr lang="en-US" sz="1400" dirty="0" err="1" smtClean="0">
                 <a:solidFill>
                   <a:srgbClr val="4A5968"/>
                 </a:solidFill>
                 <a:latin typeface="Segoe UI"/>
               </a:rPr>
-              <a:t>Pravilnyy vybor dolzhen byt svyazan s defektom ili nekomplektnostyu, a ne s vizualnoy 'staryu' detaley.</a:t>
-            </a:r>
-            <a:endParaRPr lang="ru-RU" sz="1080">
+              <a:t>Pravilnyy</a:t>
+            </a:r>
+            <a:r>
+              <a:rPr lang="en-US" sz="1400" dirty="0" smtClean="0">
+                <a:solidFill>
+                  <a:srgbClr val="4A5968"/>
+                </a:solidFill>
+                <a:latin typeface="Segoe UI"/>
+              </a:rPr>
+              <a:t> </a:t>
+            </a:r>
+            <a:r>
+              <a:rPr lang="en-US" sz="1400" dirty="0" err="1" smtClean="0">
+                <a:solidFill>
+                  <a:srgbClr val="4A5968"/>
+                </a:solidFill>
+                <a:latin typeface="Segoe UI"/>
+              </a:rPr>
+              <a:t>vybor</a:t>
+            </a:r>
+            <a:r>
+              <a:rPr lang="en-US" sz="1400" dirty="0" smtClean="0">
+                <a:solidFill>
+                  <a:srgbClr val="4A5968"/>
+                </a:solidFill>
+                <a:latin typeface="Segoe UI"/>
+              </a:rPr>
+              <a:t> </a:t>
+            </a:r>
+            <a:r>
+              <a:rPr lang="en-US" sz="1400" dirty="0" err="1" smtClean="0">
+                <a:solidFill>
+                  <a:srgbClr val="4A5968"/>
+                </a:solidFill>
+                <a:latin typeface="Segoe UI"/>
+              </a:rPr>
+              <a:t>dolzhen</a:t>
+            </a:r>
+            <a:r>
+              <a:rPr lang="en-US" sz="1400" dirty="0" smtClean="0">
+                <a:solidFill>
+                  <a:srgbClr val="4A5968"/>
+                </a:solidFill>
+                <a:latin typeface="Segoe UI"/>
+              </a:rPr>
+              <a:t> </a:t>
+            </a:r>
+            <a:r>
+              <a:rPr lang="en-US" sz="1400" dirty="0" err="1" smtClean="0">
+                <a:solidFill>
+                  <a:srgbClr val="4A5968"/>
+                </a:solidFill>
+                <a:latin typeface="Segoe UI"/>
+              </a:rPr>
+              <a:t>byt</a:t>
+            </a:r>
+            <a:r>
+              <a:rPr lang="en-US" sz="1400" dirty="0" smtClean="0">
+                <a:solidFill>
+                  <a:srgbClr val="4A5968"/>
+                </a:solidFill>
+                <a:latin typeface="Segoe UI"/>
+              </a:rPr>
+              <a:t> </a:t>
+            </a:r>
+            <a:r>
+              <a:rPr lang="en-US" sz="1400" dirty="0" err="1" smtClean="0">
+                <a:solidFill>
+                  <a:srgbClr val="4A5968"/>
+                </a:solidFill>
+                <a:latin typeface="Segoe UI"/>
+              </a:rPr>
+              <a:t>svyazan</a:t>
+            </a:r>
+            <a:r>
+              <a:rPr lang="en-US" sz="1400" dirty="0" smtClean="0">
+                <a:solidFill>
+                  <a:srgbClr val="4A5968"/>
+                </a:solidFill>
+                <a:latin typeface="Segoe UI"/>
+              </a:rPr>
+              <a:t> s </a:t>
+            </a:r>
+            <a:r>
+              <a:rPr lang="en-US" sz="1400" dirty="0" err="1" smtClean="0">
+                <a:solidFill>
+                  <a:srgbClr val="4A5968"/>
+                </a:solidFill>
+                <a:latin typeface="Segoe UI"/>
+              </a:rPr>
+              <a:t>defektom</a:t>
+            </a:r>
+            <a:r>
+              <a:rPr lang="en-US" sz="1400" dirty="0" smtClean="0">
+                <a:solidFill>
+                  <a:srgbClr val="4A5968"/>
+                </a:solidFill>
+                <a:latin typeface="Segoe UI"/>
+              </a:rPr>
+              <a:t> </a:t>
+            </a:r>
+            <a:r>
+              <a:rPr lang="en-US" sz="1400" dirty="0" err="1" smtClean="0">
+                <a:solidFill>
+                  <a:srgbClr val="4A5968"/>
+                </a:solidFill>
+                <a:latin typeface="Segoe UI"/>
+              </a:rPr>
+              <a:t>ili</a:t>
+            </a:r>
+            <a:r>
+              <a:rPr lang="en-US" sz="1400" dirty="0" smtClean="0">
+                <a:solidFill>
+                  <a:srgbClr val="4A5968"/>
+                </a:solidFill>
+                <a:latin typeface="Segoe UI"/>
+              </a:rPr>
+              <a:t> </a:t>
+            </a:r>
+            <a:r>
+              <a:rPr lang="en-US" sz="1400" dirty="0" err="1" smtClean="0">
+                <a:solidFill>
+                  <a:srgbClr val="4A5968"/>
+                </a:solidFill>
+                <a:latin typeface="Segoe UI"/>
+              </a:rPr>
+              <a:t>nekomplektnostyu</a:t>
+            </a:r>
+            <a:r>
+              <a:rPr lang="en-US" sz="1400" dirty="0" smtClean="0">
+                <a:solidFill>
+                  <a:srgbClr val="4A5968"/>
+                </a:solidFill>
+                <a:latin typeface="Segoe UI"/>
+              </a:rPr>
+              <a:t>, a ne s </a:t>
+            </a:r>
+            <a:r>
+              <a:rPr lang="en-US" sz="1400" dirty="0" err="1" smtClean="0">
+                <a:solidFill>
+                  <a:srgbClr val="4A5968"/>
+                </a:solidFill>
+                <a:latin typeface="Segoe UI"/>
+              </a:rPr>
+              <a:t>vizualnoy</a:t>
+            </a:r>
+            <a:r>
+              <a:rPr lang="en-US" sz="1400" dirty="0" smtClean="0">
+                <a:solidFill>
+                  <a:srgbClr val="4A5968"/>
+                </a:solidFill>
+                <a:latin typeface="Segoe UI"/>
+              </a:rPr>
+              <a:t> '</a:t>
+            </a:r>
+            <a:r>
+              <a:rPr lang="en-US" sz="1400" dirty="0" err="1" smtClean="0">
+                <a:solidFill>
+                  <a:srgbClr val="4A5968"/>
+                </a:solidFill>
+                <a:latin typeface="Segoe UI"/>
+              </a:rPr>
+              <a:t>staryu</a:t>
+            </a:r>
+            <a:r>
+              <a:rPr lang="en-US" sz="1400" dirty="0" smtClean="0">
+                <a:solidFill>
+                  <a:srgbClr val="4A5968"/>
+                </a:solidFill>
+                <a:latin typeface="Segoe UI"/>
+              </a:rPr>
+              <a:t>' </a:t>
+            </a:r>
+            <a:r>
+              <a:rPr lang="en-US" sz="1400" dirty="0" err="1" smtClean="0">
+                <a:solidFill>
+                  <a:srgbClr val="4A5968"/>
+                </a:solidFill>
+                <a:latin typeface="Segoe UI"/>
+              </a:rPr>
+              <a:t>detaley</a:t>
+            </a:r>
+            <a:r>
+              <a:rPr lang="en-US" sz="1400" dirty="0" smtClean="0">
+                <a:solidFill>
+                  <a:srgbClr val="4A5968"/>
+                </a:solidFill>
+                <a:latin typeface="Segoe UI"/>
+              </a:rPr>
+              <a:t>.</a:t>
+            </a:r>
+            <a:endParaRPr lang="ru-RU" sz="1400" dirty="0">
               <a:solidFill>
                 <a:srgbClr val="4A5968"/>
               </a:solidFill>
@@ -6797,7 +7709,7 @@
     </p:spTree>
     <p:extLst>
       <p:ext uri="{BB962C8B-B14F-4D97-AF65-F5344CB8AC3E}">
-        <p14:creationId xmlns:p14="http://schemas.microsoft.com/office/powerpoint/2010/main" val="1338908168"/>
+        <p14:creationId xmlns:p14="http://schemas.microsoft.com/office/powerpoint/2010/main" val="3185316205"/>
       </p:ext>
     </p:extLst>
   </p:cSld>
@@ -8532,7 +9444,7 @@
     </p:spTree>
     <p:extLst>
       <p:ext uri="{BB962C8B-B14F-4D97-AF65-F5344CB8AC3E}">
-        <p14:creationId xmlns:p14="http://schemas.microsoft.com/office/powerpoint/2010/main" val="4255657533"/>
+        <p14:creationId xmlns:p14="http://schemas.microsoft.com/office/powerpoint/2010/main" val="1194585212"/>
       </p:ext>
     </p:extLst>
   </p:cSld>
@@ -10689,7 +11601,7 @@
     </p:spTree>
     <p:extLst>
       <p:ext uri="{BB962C8B-B14F-4D97-AF65-F5344CB8AC3E}">
-        <p14:creationId xmlns:p14="http://schemas.microsoft.com/office/powerpoint/2010/main" val="2348083802"/>
+        <p14:creationId xmlns:p14="http://schemas.microsoft.com/office/powerpoint/2010/main" val="2918887528"/>
       </p:ext>
     </p:extLst>
   </p:cSld>
@@ -12508,7 +13420,7 @@
     </p:spTree>
     <p:extLst>
       <p:ext uri="{BB962C8B-B14F-4D97-AF65-F5344CB8AC3E}">
-        <p14:creationId xmlns:p14="http://schemas.microsoft.com/office/powerpoint/2010/main" val="850308361"/>
+        <p14:creationId xmlns:p14="http://schemas.microsoft.com/office/powerpoint/2010/main" val="1011726781"/>
       </p:ext>
     </p:extLst>
   </p:cSld>

</xml_diff>